<commit_message>
Actualiza presentación del proyecto
</commit_message>
<xml_diff>
--- a/Fase 1/Evidencias Grupales/Presentación Proyecto.pptx
+++ b/Fase 1/Evidencias Grupales/Presentación Proyecto.pptx
@@ -1598,7 +1598,7 @@
   <p:cSld>
     <p:spTree>
       <p:nvGrpSpPr>
-        <p:cNvPr id="299" name="Shape 299"/>
+        <p:cNvPr id="284" name="Shape 284"/>
         <p:cNvGrpSpPr/>
         <p:nvPr/>
       </p:nvGrpSpPr>
@@ -1612,7 +1612,7 @@
       </p:grpSpPr>
       <p:sp>
         <p:nvSpPr>
-          <p:cNvPr id="300" name="Google Shape;300;p10:notes"/>
+          <p:cNvPr id="285" name="Google Shape;285;p10:notes"/>
           <p:cNvSpPr/>
           <p:nvPr>
             <p:ph idx="2" type="sldImg"/>
@@ -1657,7 +1657,7 @@
       </p:sp>
       <p:sp>
         <p:nvSpPr>
-          <p:cNvPr id="301" name="Google Shape;301;p10:notes"/>
+          <p:cNvPr id="286" name="Google Shape;286;p10:notes"/>
           <p:cNvSpPr txBox="1"/>
           <p:nvPr>
             <p:ph idx="1" type="body"/>
@@ -1701,7 +1701,7 @@
       </p:sp>
       <p:sp>
         <p:nvSpPr>
-          <p:cNvPr id="302" name="Google Shape;302;p10:notes"/>
+          <p:cNvPr id="287" name="Google Shape;287;p10:notes"/>
           <p:cNvSpPr txBox="1"/>
           <p:nvPr>
             <p:ph idx="12" type="sldNum"/>
@@ -2072,7 +2072,7 @@
   <p:cSld>
     <p:spTree>
       <p:nvGrpSpPr>
-        <p:cNvPr id="74" name="Shape 74"/>
+        <p:cNvPr id="75" name="Shape 75"/>
         <p:cNvGrpSpPr/>
         <p:nvPr/>
       </p:nvGrpSpPr>
@@ -2086,7 +2086,7 @@
       </p:grpSpPr>
       <p:sp>
         <p:nvSpPr>
-          <p:cNvPr id="75" name="Google Shape;75;p4:notes"/>
+          <p:cNvPr id="76" name="Google Shape;76;p4:notes"/>
           <p:cNvSpPr/>
           <p:nvPr>
             <p:ph idx="2" type="sldImg"/>
@@ -2131,7 +2131,7 @@
       </p:sp>
       <p:sp>
         <p:nvSpPr>
-          <p:cNvPr id="76" name="Google Shape;76;p4:notes"/>
+          <p:cNvPr id="77" name="Google Shape;77;p4:notes"/>
           <p:cNvSpPr txBox="1"/>
           <p:nvPr>
             <p:ph idx="1" type="body"/>
@@ -2175,7 +2175,7 @@
       </p:sp>
       <p:sp>
         <p:nvSpPr>
-          <p:cNvPr id="77" name="Google Shape;77;p4:notes"/>
+          <p:cNvPr id="78" name="Google Shape;78;p4:notes"/>
           <p:cNvSpPr txBox="1"/>
           <p:nvPr>
             <p:ph idx="12" type="sldNum"/>
@@ -2230,7 +2230,7 @@
   <p:cSld>
     <p:spTree>
       <p:nvGrpSpPr>
-        <p:cNvPr id="109" name="Shape 109"/>
+        <p:cNvPr id="106" name="Shape 106"/>
         <p:cNvGrpSpPr/>
         <p:nvPr/>
       </p:nvGrpSpPr>
@@ -2244,7 +2244,7 @@
       </p:grpSpPr>
       <p:sp>
         <p:nvSpPr>
-          <p:cNvPr id="110" name="Google Shape;110;p5:notes"/>
+          <p:cNvPr id="107" name="Google Shape;107;p5:notes"/>
           <p:cNvSpPr/>
           <p:nvPr>
             <p:ph idx="2" type="sldImg"/>
@@ -2289,7 +2289,7 @@
       </p:sp>
       <p:sp>
         <p:nvSpPr>
-          <p:cNvPr id="111" name="Google Shape;111;p5:notes"/>
+          <p:cNvPr id="108" name="Google Shape;108;p5:notes"/>
           <p:cNvSpPr txBox="1"/>
           <p:nvPr>
             <p:ph idx="1" type="body"/>
@@ -2333,7 +2333,7 @@
       </p:sp>
       <p:sp>
         <p:nvSpPr>
-          <p:cNvPr id="112" name="Google Shape;112;p5:notes"/>
+          <p:cNvPr id="109" name="Google Shape;109;p5:notes"/>
           <p:cNvSpPr txBox="1"/>
           <p:nvPr>
             <p:ph idx="12" type="sldNum"/>
@@ -2388,7 +2388,7 @@
   <p:cSld>
     <p:spTree>
       <p:nvGrpSpPr>
-        <p:cNvPr id="146" name="Shape 146"/>
+        <p:cNvPr id="135" name="Shape 135"/>
         <p:cNvGrpSpPr/>
         <p:nvPr/>
       </p:nvGrpSpPr>
@@ -2402,7 +2402,7 @@
       </p:grpSpPr>
       <p:sp>
         <p:nvSpPr>
-          <p:cNvPr id="147" name="Google Shape;147;p6:notes"/>
+          <p:cNvPr id="136" name="Google Shape;136;p6:notes"/>
           <p:cNvSpPr/>
           <p:nvPr>
             <p:ph idx="2" type="sldImg"/>
@@ -2447,7 +2447,7 @@
       </p:sp>
       <p:sp>
         <p:nvSpPr>
-          <p:cNvPr id="148" name="Google Shape;148;p6:notes"/>
+          <p:cNvPr id="137" name="Google Shape;137;p6:notes"/>
           <p:cNvSpPr txBox="1"/>
           <p:nvPr>
             <p:ph idx="1" type="body"/>
@@ -2491,7 +2491,7 @@
       </p:sp>
       <p:sp>
         <p:nvSpPr>
-          <p:cNvPr id="149" name="Google Shape;149;p6:notes"/>
+          <p:cNvPr id="138" name="Google Shape;138;p6:notes"/>
           <p:cNvSpPr txBox="1"/>
           <p:nvPr>
             <p:ph idx="12" type="sldNum"/>
@@ -2546,7 +2546,7 @@
   <p:cSld>
     <p:spTree>
       <p:nvGrpSpPr>
-        <p:cNvPr id="183" name="Shape 183"/>
+        <p:cNvPr id="172" name="Shape 172"/>
         <p:cNvGrpSpPr/>
         <p:nvPr/>
       </p:nvGrpSpPr>
@@ -2560,7 +2560,7 @@
       </p:grpSpPr>
       <p:sp>
         <p:nvSpPr>
-          <p:cNvPr id="184" name="Google Shape;184;p7:notes"/>
+          <p:cNvPr id="173" name="Google Shape;173;p7:notes"/>
           <p:cNvSpPr/>
           <p:nvPr>
             <p:ph idx="2" type="sldImg"/>
@@ -2605,7 +2605,7 @@
       </p:sp>
       <p:sp>
         <p:nvSpPr>
-          <p:cNvPr id="185" name="Google Shape;185;p7:notes"/>
+          <p:cNvPr id="174" name="Google Shape;174;p7:notes"/>
           <p:cNvSpPr txBox="1"/>
           <p:nvPr>
             <p:ph idx="1" type="body"/>
@@ -2649,7 +2649,7 @@
       </p:sp>
       <p:sp>
         <p:nvSpPr>
-          <p:cNvPr id="186" name="Google Shape;186;p7:notes"/>
+          <p:cNvPr id="175" name="Google Shape;175;p7:notes"/>
           <p:cNvSpPr txBox="1"/>
           <p:nvPr>
             <p:ph idx="12" type="sldNum"/>
@@ -2704,7 +2704,7 @@
   <p:cSld>
     <p:spTree>
       <p:nvGrpSpPr>
-        <p:cNvPr id="238" name="Shape 238"/>
+        <p:cNvPr id="227" name="Shape 227"/>
         <p:cNvGrpSpPr/>
         <p:nvPr/>
       </p:nvGrpSpPr>
@@ -2718,7 +2718,7 @@
       </p:grpSpPr>
       <p:sp>
         <p:nvSpPr>
-          <p:cNvPr id="239" name="Google Shape;239;p8:notes"/>
+          <p:cNvPr id="228" name="Google Shape;228;p8:notes"/>
           <p:cNvSpPr/>
           <p:nvPr>
             <p:ph idx="2" type="sldImg"/>
@@ -2763,7 +2763,7 @@
       </p:sp>
       <p:sp>
         <p:nvSpPr>
-          <p:cNvPr id="240" name="Google Shape;240;p8:notes"/>
+          <p:cNvPr id="229" name="Google Shape;229;p8:notes"/>
           <p:cNvSpPr txBox="1"/>
           <p:nvPr>
             <p:ph idx="1" type="body"/>
@@ -2807,7 +2807,7 @@
       </p:sp>
       <p:sp>
         <p:nvSpPr>
-          <p:cNvPr id="241" name="Google Shape;241;p8:notes"/>
+          <p:cNvPr id="230" name="Google Shape;230;p8:notes"/>
           <p:cNvSpPr txBox="1"/>
           <p:nvPr>
             <p:ph idx="12" type="sldNum"/>
@@ -2862,7 +2862,7 @@
   <p:cSld>
     <p:spTree>
       <p:nvGrpSpPr>
-        <p:cNvPr id="267" name="Shape 267"/>
+        <p:cNvPr id="256" name="Shape 256"/>
         <p:cNvGrpSpPr/>
         <p:nvPr/>
       </p:nvGrpSpPr>
@@ -2876,7 +2876,7 @@
       </p:grpSpPr>
       <p:sp>
         <p:nvSpPr>
-          <p:cNvPr id="268" name="Google Shape;268;p9:notes"/>
+          <p:cNvPr id="257" name="Google Shape;257;p9:notes"/>
           <p:cNvSpPr/>
           <p:nvPr>
             <p:ph idx="2" type="sldImg"/>
@@ -2921,7 +2921,7 @@
       </p:sp>
       <p:sp>
         <p:nvSpPr>
-          <p:cNvPr id="269" name="Google Shape;269;p9:notes"/>
+          <p:cNvPr id="258" name="Google Shape;258;p9:notes"/>
           <p:cNvSpPr txBox="1"/>
           <p:nvPr>
             <p:ph idx="1" type="body"/>
@@ -2965,7 +2965,7 @@
       </p:sp>
       <p:sp>
         <p:nvSpPr>
-          <p:cNvPr id="270" name="Google Shape;270;p9:notes"/>
+          <p:cNvPr id="259" name="Google Shape;259;p9:notes"/>
           <p:cNvSpPr txBox="1"/>
           <p:nvPr>
             <p:ph idx="12" type="sldNum"/>
@@ -4543,7 +4543,7 @@
     </p:bg>
     <p:spTree>
       <p:nvGrpSpPr>
-        <p:cNvPr id="303" name="Shape 303"/>
+        <p:cNvPr id="288" name="Shape 288"/>
         <p:cNvGrpSpPr/>
         <p:nvPr/>
       </p:nvGrpSpPr>
@@ -4557,7 +4557,7 @@
       </p:grpSpPr>
       <p:sp>
         <p:nvSpPr>
-          <p:cNvPr id="304" name="Google Shape;304;p12"/>
+          <p:cNvPr id="289" name="Google Shape;289;p12"/>
           <p:cNvSpPr/>
           <p:nvPr/>
         </p:nvSpPr>
@@ -4620,7 +4620,7 @@
       </p:sp>
       <p:sp>
         <p:nvSpPr>
-          <p:cNvPr id="305" name="Google Shape;305;p12"/>
+          <p:cNvPr id="290" name="Google Shape;290;p12"/>
           <p:cNvSpPr/>
           <p:nvPr/>
         </p:nvSpPr>
@@ -4686,7 +4686,7 @@
       </p:sp>
       <p:sp>
         <p:nvSpPr>
-          <p:cNvPr id="306" name="Google Shape;306;p12"/>
+          <p:cNvPr id="291" name="Google Shape;291;p12"/>
           <p:cNvSpPr/>
           <p:nvPr/>
         </p:nvSpPr>
@@ -4729,7 +4729,7 @@
       </p:sp>
       <p:sp>
         <p:nvSpPr>
-          <p:cNvPr id="307" name="Google Shape;307;p12"/>
+          <p:cNvPr id="292" name="Google Shape;292;p12"/>
           <p:cNvSpPr/>
           <p:nvPr/>
         </p:nvSpPr>
@@ -4795,7 +4795,7 @@
       </p:sp>
       <p:sp>
         <p:nvSpPr>
-          <p:cNvPr id="308" name="Google Shape;308;p12"/>
+          <p:cNvPr id="293" name="Google Shape;293;p12"/>
           <p:cNvSpPr/>
           <p:nvPr/>
         </p:nvSpPr>
@@ -4858,7 +4858,7 @@
       </p:sp>
       <p:sp>
         <p:nvSpPr>
-          <p:cNvPr id="309" name="Google Shape;309;p12"/>
+          <p:cNvPr id="294" name="Google Shape;294;p12"/>
           <p:cNvSpPr/>
           <p:nvPr/>
         </p:nvSpPr>
@@ -4921,7 +4921,7 @@
       </p:sp>
       <p:sp>
         <p:nvSpPr>
-          <p:cNvPr id="310" name="Google Shape;310;p12"/>
+          <p:cNvPr id="295" name="Google Shape;295;p12"/>
           <p:cNvSpPr/>
           <p:nvPr/>
         </p:nvSpPr>
@@ -4984,7 +4984,7 @@
       </p:sp>
       <p:sp>
         <p:nvSpPr>
-          <p:cNvPr id="311" name="Google Shape;311;p12"/>
+          <p:cNvPr id="296" name="Google Shape;296;p12"/>
           <p:cNvSpPr/>
           <p:nvPr/>
         </p:nvSpPr>
@@ -5237,7 +5237,31 @@
                 <a:cs typeface="Source Serif 4"/>
                 <a:sym typeface="Source Serif 4"/>
               </a:rPr>
-              <a:t>Una experiencia de realidad virtual que convierte la emoción en datos útiles para el aula</a:t>
+              <a:t>Una experiencia de </a:t>
+            </a:r>
+            <a:r>
+              <a:rPr b="0" i="0" lang="en-US" sz="5700" u="none" cap="none" strike="noStrike">
+                <a:solidFill>
+                  <a:srgbClr val="0F3460"/>
+                </a:solidFill>
+                <a:latin typeface="Source Serif 4"/>
+                <a:ea typeface="Source Serif 4"/>
+                <a:cs typeface="Source Serif 4"/>
+                <a:sym typeface="Source Serif 4"/>
+              </a:rPr>
+              <a:t>realidad virtual </a:t>
+            </a:r>
+            <a:r>
+              <a:rPr b="0" i="0" lang="en-US" sz="5700" u="none" cap="none" strike="noStrike">
+                <a:solidFill>
+                  <a:srgbClr val="0F3460"/>
+                </a:solidFill>
+                <a:latin typeface="Source Serif 4"/>
+                <a:ea typeface="Source Serif 4"/>
+                <a:cs typeface="Source Serif 4"/>
+                <a:sym typeface="Source Serif 4"/>
+              </a:rPr>
+              <a:t>que convierte la emoción en datos útiles para el aula</a:t>
             </a:r>
             <a:endParaRPr b="0" i="0" sz="5700" u="none" cap="none" strike="noStrike">
               <a:solidFill>
@@ -6245,8 +6269,8 @@
         </p:nvSpPr>
         <p:spPr>
           <a:xfrm>
-            <a:off x="952500" y="1726136"/>
-            <a:ext cx="14716125" cy="2489597"/>
+            <a:off x="869575" y="3698000"/>
+            <a:ext cx="10797600" cy="838200"/>
           </a:xfrm>
           <a:prstGeom prst="rect">
             <a:avLst/>
@@ -6289,7 +6313,7 @@
                 <a:cs typeface="Source Serif 4"/>
                 <a:sym typeface="Source Serif 4"/>
               </a:rPr>
-              <a:t>Los colegios enseñan a ciegas: no pueden medir cómo se siente ni cómo atiende su curso</a:t>
+              <a:t>Los colegios enseñan a ciegas</a:t>
             </a:r>
             <a:endParaRPr b="0" i="0" sz="5850" u="none" cap="none" strike="noStrike">
               <a:solidFill>
@@ -6311,8 +6335,8 @@
         </p:nvSpPr>
         <p:spPr>
           <a:xfrm>
-            <a:off x="952500" y="4558633"/>
-            <a:ext cx="15297150" cy="509587"/>
+            <a:off x="952500" y="5115258"/>
+            <a:ext cx="15297300" cy="509700"/>
           </a:xfrm>
           <a:prstGeom prst="rect">
             <a:avLst/>
@@ -6377,8 +6401,8 @@
         </p:nvSpPr>
         <p:spPr>
           <a:xfrm>
-            <a:off x="952500" y="5754021"/>
-            <a:ext cx="5105400" cy="2246611"/>
+            <a:off x="982025" y="5873296"/>
+            <a:ext cx="5105400" cy="2246700"/>
           </a:xfrm>
           <a:prstGeom prst="rect">
             <a:avLst/>
@@ -6422,8 +6446,8 @@
         </p:nvSpPr>
         <p:spPr>
           <a:xfrm>
-            <a:off x="952500" y="5754021"/>
-            <a:ext cx="5105400" cy="25400"/>
+            <a:off x="869575" y="5802796"/>
+            <a:ext cx="5105400" cy="25500"/>
           </a:xfrm>
           <a:prstGeom prst="rect">
             <a:avLst/>
@@ -6467,8 +6491,8 @@
         </p:nvSpPr>
         <p:spPr>
           <a:xfrm>
-            <a:off x="1333500" y="6198520"/>
-            <a:ext cx="4777740" cy="449561"/>
+            <a:off x="1363025" y="6317795"/>
+            <a:ext cx="4777800" cy="449700"/>
           </a:xfrm>
           <a:prstGeom prst="rect">
             <a:avLst/>
@@ -6533,8 +6557,8 @@
         </p:nvSpPr>
         <p:spPr>
           <a:xfrm>
-            <a:off x="1333500" y="6781431"/>
-            <a:ext cx="4473702" cy="838200"/>
+            <a:off x="1363025" y="6900706"/>
+            <a:ext cx="4473600" cy="838200"/>
           </a:xfrm>
           <a:prstGeom prst="rect">
             <a:avLst/>
@@ -6599,8 +6623,8 @@
         </p:nvSpPr>
         <p:spPr>
           <a:xfrm>
-            <a:off x="6591300" y="5754021"/>
-            <a:ext cx="5105400" cy="2246611"/>
+            <a:off x="6620825" y="5873296"/>
+            <a:ext cx="5105400" cy="2246700"/>
           </a:xfrm>
           <a:prstGeom prst="rect">
             <a:avLst/>
@@ -6644,8 +6668,8 @@
         </p:nvSpPr>
         <p:spPr>
           <a:xfrm>
-            <a:off x="6591300" y="5754021"/>
-            <a:ext cx="5105400" cy="25400"/>
+            <a:off x="6620825" y="5873296"/>
+            <a:ext cx="5105400" cy="25500"/>
           </a:xfrm>
           <a:prstGeom prst="rect">
             <a:avLst/>
@@ -6689,8 +6713,8 @@
         </p:nvSpPr>
         <p:spPr>
           <a:xfrm>
-            <a:off x="6972300" y="6198520"/>
-            <a:ext cx="4777740" cy="449561"/>
+            <a:off x="7001825" y="6317795"/>
+            <a:ext cx="4777800" cy="449700"/>
           </a:xfrm>
           <a:prstGeom prst="rect">
             <a:avLst/>
@@ -6755,8 +6779,8 @@
         </p:nvSpPr>
         <p:spPr>
           <a:xfrm>
-            <a:off x="6972300" y="6781431"/>
-            <a:ext cx="4473702" cy="838200"/>
+            <a:off x="7001825" y="6900706"/>
+            <a:ext cx="4473600" cy="838200"/>
           </a:xfrm>
           <a:prstGeom prst="rect">
             <a:avLst/>
@@ -6821,8 +6845,8 @@
         </p:nvSpPr>
         <p:spPr>
           <a:xfrm>
-            <a:off x="12230100" y="5754021"/>
-            <a:ext cx="5105400" cy="2246611"/>
+            <a:off x="12259625" y="5873296"/>
+            <a:ext cx="5105400" cy="2246700"/>
           </a:xfrm>
           <a:prstGeom prst="rect">
             <a:avLst/>
@@ -6866,8 +6890,8 @@
         </p:nvSpPr>
         <p:spPr>
           <a:xfrm>
-            <a:off x="12230100" y="5754021"/>
-            <a:ext cx="5105400" cy="25400"/>
+            <a:off x="12259625" y="5873296"/>
+            <a:ext cx="5105400" cy="25500"/>
           </a:xfrm>
           <a:prstGeom prst="rect">
             <a:avLst/>
@@ -6911,8 +6935,8 @@
         </p:nvSpPr>
         <p:spPr>
           <a:xfrm>
-            <a:off x="12611100" y="6198520"/>
-            <a:ext cx="4777740" cy="449561"/>
+            <a:off x="12640625" y="6317795"/>
+            <a:ext cx="4777800" cy="449700"/>
           </a:xfrm>
           <a:prstGeom prst="rect">
             <a:avLst/>
@@ -6977,8 +7001,8 @@
         </p:nvSpPr>
         <p:spPr>
           <a:xfrm>
-            <a:off x="12611100" y="6781431"/>
-            <a:ext cx="4473702" cy="838200"/>
+            <a:off x="12640625" y="6900706"/>
+            <a:ext cx="4473600" cy="838200"/>
           </a:xfrm>
           <a:prstGeom prst="rect">
             <a:avLst/>
@@ -7161,6 +7185,34 @@
           </a:p>
         </p:txBody>
       </p:sp>
+      <p:pic>
+        <p:nvPicPr>
+          <p:cNvPr id="74" name="Google Shape;74;p5"/>
+          <p:cNvPicPr preferRelativeResize="0"/>
+          <p:nvPr/>
+        </p:nvPicPr>
+        <p:blipFill>
+          <a:blip r:embed="rId3">
+            <a:alphaModFix/>
+          </a:blip>
+          <a:stretch>
+            <a:fillRect/>
+          </a:stretch>
+        </p:blipFill>
+        <p:spPr>
+          <a:xfrm>
+            <a:off x="11475425" y="952500"/>
+            <a:ext cx="6086475" cy="4286250"/>
+          </a:xfrm>
+          <a:prstGeom prst="rect">
+            <a:avLst/>
+          </a:prstGeom>
+          <a:noFill/>
+          <a:ln>
+            <a:noFill/>
+          </a:ln>
+        </p:spPr>
+      </p:pic>
     </p:spTree>
   </p:cSld>
   <p:clrMapOvr>
@@ -7181,7 +7233,7 @@
     </p:bg>
     <p:spTree>
       <p:nvGrpSpPr>
-        <p:cNvPr id="78" name="Shape 78"/>
+        <p:cNvPr id="79" name="Shape 79"/>
         <p:cNvGrpSpPr/>
         <p:nvPr/>
       </p:nvGrpSpPr>
@@ -7195,7 +7247,7 @@
       </p:grpSpPr>
       <p:sp>
         <p:nvSpPr>
-          <p:cNvPr id="79" name="Google Shape;79;p6"/>
+          <p:cNvPr id="80" name="Google Shape;80;p6"/>
           <p:cNvSpPr/>
           <p:nvPr/>
         </p:nvSpPr>
@@ -7240,7 +7292,7 @@
       </p:sp>
       <p:sp>
         <p:nvSpPr>
-          <p:cNvPr id="80" name="Google Shape;80;p6"/>
+          <p:cNvPr id="81" name="Google Shape;81;p6"/>
           <p:cNvSpPr/>
           <p:nvPr/>
         </p:nvSpPr>
@@ -7303,14 +7355,14 @@
       </p:sp>
       <p:sp>
         <p:nvSpPr>
-          <p:cNvPr id="81" name="Google Shape;81;p6"/>
+          <p:cNvPr id="82" name="Google Shape;82;p6"/>
           <p:cNvSpPr/>
           <p:nvPr/>
         </p:nvSpPr>
         <p:spPr>
           <a:xfrm>
             <a:off x="952500" y="1723362"/>
-            <a:ext cx="13735050" cy="1672431"/>
+            <a:ext cx="13735200" cy="1672500"/>
           </a:xfrm>
           <a:prstGeom prst="rect">
             <a:avLst/>
@@ -7369,14 +7421,14 @@
       </p:sp>
       <p:sp>
         <p:nvSpPr>
-          <p:cNvPr id="82" name="Google Shape;82;p6"/>
+          <p:cNvPr id="83" name="Google Shape;83;p6"/>
           <p:cNvSpPr/>
           <p:nvPr/>
         </p:nvSpPr>
         <p:spPr>
           <a:xfrm>
             <a:off x="952500" y="3700594"/>
-            <a:ext cx="14716125" cy="952500"/>
+            <a:ext cx="14716200" cy="952500"/>
           </a:xfrm>
           <a:prstGeom prst="rect">
             <a:avLst/>
@@ -7435,14 +7487,14 @@
       </p:sp>
       <p:sp>
         <p:nvSpPr>
-          <p:cNvPr id="83" name="Google Shape;83;p6"/>
+          <p:cNvPr id="84" name="Google Shape;84;p6"/>
           <p:cNvSpPr/>
           <p:nvPr/>
         </p:nvSpPr>
         <p:spPr>
           <a:xfrm>
             <a:off x="1276350" y="5615782"/>
-            <a:ext cx="14416867" cy="19050"/>
+            <a:ext cx="14416800" cy="19200"/>
           </a:xfrm>
           <a:prstGeom prst="rect">
             <a:avLst/>
@@ -7478,7 +7530,7 @@
       </p:sp>
       <p:sp>
         <p:nvSpPr>
-          <p:cNvPr id="84" name="Google Shape;84;p6"/>
+          <p:cNvPr id="85" name="Google Shape;85;p6"/>
           <p:cNvSpPr/>
           <p:nvPr/>
         </p:nvSpPr>
@@ -7523,7 +7575,7 @@
       </p:sp>
       <p:sp>
         <p:nvSpPr>
-          <p:cNvPr id="85" name="Google Shape;85;p6"/>
+          <p:cNvPr id="86" name="Google Shape;86;p6"/>
           <p:cNvSpPr/>
           <p:nvPr/>
         </p:nvSpPr>
@@ -7586,14 +7638,14 @@
       </p:sp>
       <p:sp>
         <p:nvSpPr>
-          <p:cNvPr id="86" name="Google Shape;86;p6"/>
+          <p:cNvPr id="87" name="Google Shape;87;p6"/>
           <p:cNvSpPr/>
           <p:nvPr/>
         </p:nvSpPr>
         <p:spPr>
           <a:xfrm>
             <a:off x="952500" y="6138994"/>
-            <a:ext cx="3268980" cy="415230"/>
+            <a:ext cx="3269100" cy="415200"/>
           </a:xfrm>
           <a:prstGeom prst="rect">
             <a:avLst/>
@@ -7652,72 +7704,6 @@
       </p:sp>
       <p:sp>
         <p:nvSpPr>
-          <p:cNvPr id="87" name="Google Shape;87;p6"/>
-          <p:cNvSpPr/>
-          <p:nvPr/>
-        </p:nvSpPr>
-        <p:spPr>
-          <a:xfrm>
-            <a:off x="952500" y="6706624"/>
-            <a:ext cx="3060954" cy="781050"/>
-          </a:xfrm>
-          <a:prstGeom prst="rect">
-            <a:avLst/>
-          </a:prstGeom>
-          <a:noFill/>
-          <a:ln>
-            <a:noFill/>
-          </a:ln>
-        </p:spPr>
-        <p:txBody>
-          <a:bodyPr anchorCtr="0" anchor="t" bIns="25400" lIns="25400" spcFirstLastPara="1" rIns="25400" wrap="square" tIns="25400">
-            <a:noAutofit/>
-          </a:bodyPr>
-          <a:lstStyle/>
-          <a:p>
-            <a:pPr indent="0" lvl="0" marL="0" marR="0" rtl="0" algn="l">
-              <a:lnSpc>
-                <a:spcPct val="108333"/>
-              </a:lnSpc>
-              <a:spcBef>
-                <a:spcPts val="0"/>
-              </a:spcBef>
-              <a:spcAft>
-                <a:spcPts val="0"/>
-              </a:spcAft>
-              <a:buClr>
-                <a:srgbClr val="4A4A4A"/>
-              </a:buClr>
-              <a:buSzPts val="1950"/>
-              <a:buFont typeface="Manrope"/>
-              <a:buNone/>
-            </a:pPr>
-            <a:r>
-              <a:rPr b="0" i="0" lang="en-US" sz="1950" u="none" cap="none" strike="noStrike">
-                <a:solidFill>
-                  <a:srgbClr val="4A4A4A"/>
-                </a:solidFill>
-                <a:latin typeface="Manrope"/>
-                <a:ea typeface="Manrope"/>
-                <a:cs typeface="Manrope"/>
-                <a:sym typeface="Manrope"/>
-              </a:rPr>
-              <a:t>Check-in emocional inicial.</a:t>
-            </a:r>
-            <a:endParaRPr b="0" i="0" sz="1950" u="none" cap="none" strike="noStrike">
-              <a:solidFill>
-                <a:schemeClr val="dk1"/>
-              </a:solidFill>
-              <a:latin typeface="Calibri"/>
-              <a:ea typeface="Calibri"/>
-              <a:cs typeface="Calibri"/>
-              <a:sym typeface="Calibri"/>
-            </a:endParaRPr>
-          </a:p>
-        </p:txBody>
-      </p:sp>
-      <p:sp>
-        <p:nvSpPr>
           <p:cNvPr id="88" name="Google Shape;88;p6"/>
           <p:cNvSpPr/>
           <p:nvPr/>
@@ -7833,7 +7819,7 @@
         <p:spPr>
           <a:xfrm>
             <a:off x="4305300" y="6138994"/>
-            <a:ext cx="3268980" cy="415230"/>
+            <a:ext cx="3269100" cy="415200"/>
           </a:xfrm>
           <a:prstGeom prst="rect">
             <a:avLst/>
@@ -7898,72 +7884,6 @@
         </p:nvSpPr>
         <p:spPr>
           <a:xfrm>
-            <a:off x="4305300" y="6706624"/>
-            <a:ext cx="3060954" cy="781050"/>
-          </a:xfrm>
-          <a:prstGeom prst="rect">
-            <a:avLst/>
-          </a:prstGeom>
-          <a:noFill/>
-          <a:ln>
-            <a:noFill/>
-          </a:ln>
-        </p:spPr>
-        <p:txBody>
-          <a:bodyPr anchorCtr="0" anchor="t" bIns="25400" lIns="25400" spcFirstLastPara="1" rIns="25400" wrap="square" tIns="25400">
-            <a:noAutofit/>
-          </a:bodyPr>
-          <a:lstStyle/>
-          <a:p>
-            <a:pPr indent="0" lvl="0" marL="0" marR="0" rtl="0" algn="l">
-              <a:lnSpc>
-                <a:spcPct val="108333"/>
-              </a:lnSpc>
-              <a:spcBef>
-                <a:spcPts val="0"/>
-              </a:spcBef>
-              <a:spcAft>
-                <a:spcPts val="0"/>
-              </a:spcAft>
-              <a:buClr>
-                <a:srgbClr val="4A4A4A"/>
-              </a:buClr>
-              <a:buSzPts val="1950"/>
-              <a:buFont typeface="Manrope"/>
-              <a:buNone/>
-            </a:pPr>
-            <a:r>
-              <a:rPr b="0" i="0" lang="en-US" sz="1950" u="none" cap="none" strike="noStrike">
-                <a:solidFill>
-                  <a:srgbClr val="4A4A4A"/>
-                </a:solidFill>
-                <a:latin typeface="Manrope"/>
-                <a:ea typeface="Manrope"/>
-                <a:cs typeface="Manrope"/>
-                <a:sym typeface="Manrope"/>
-              </a:rPr>
-              <a:t>Interacción con exigencia moderada.</a:t>
-            </a:r>
-            <a:endParaRPr b="0" i="0" sz="1950" u="none" cap="none" strike="noStrike">
-              <a:solidFill>
-                <a:schemeClr val="dk1"/>
-              </a:solidFill>
-              <a:latin typeface="Calibri"/>
-              <a:ea typeface="Calibri"/>
-              <a:cs typeface="Calibri"/>
-              <a:sym typeface="Calibri"/>
-            </a:endParaRPr>
-          </a:p>
-        </p:txBody>
-      </p:sp>
-      <p:sp>
-        <p:nvSpPr>
-          <p:cNvPr id="92" name="Google Shape;92;p6"/>
-          <p:cNvSpPr/>
-          <p:nvPr/>
-        </p:nvSpPr>
-        <p:spPr>
-          <a:xfrm>
             <a:off x="7658100" y="5300794"/>
             <a:ext cx="647700" cy="647700"/>
           </a:xfrm>
@@ -8003,7 +7923,7 @@
       </p:sp>
       <p:sp>
         <p:nvSpPr>
-          <p:cNvPr id="93" name="Google Shape;93;p6"/>
+          <p:cNvPr id="92" name="Google Shape;92;p6"/>
           <p:cNvSpPr/>
           <p:nvPr/>
         </p:nvSpPr>
@@ -8066,14 +7986,14 @@
       </p:sp>
       <p:sp>
         <p:nvSpPr>
-          <p:cNvPr id="94" name="Google Shape;94;p6"/>
+          <p:cNvPr id="93" name="Google Shape;93;p6"/>
           <p:cNvSpPr/>
           <p:nvPr/>
         </p:nvSpPr>
         <p:spPr>
           <a:xfrm>
             <a:off x="7658100" y="6138994"/>
-            <a:ext cx="3268980" cy="415230"/>
+            <a:ext cx="3269100" cy="415200"/>
           </a:xfrm>
           <a:prstGeom prst="rect">
             <a:avLst/>
@@ -8132,73 +8052,7 @@
       </p:sp>
       <p:sp>
         <p:nvSpPr>
-          <p:cNvPr id="95" name="Google Shape;95;p6"/>
-          <p:cNvSpPr/>
-          <p:nvPr/>
-        </p:nvSpPr>
-        <p:spPr>
-          <a:xfrm>
-            <a:off x="7658100" y="6706624"/>
-            <a:ext cx="3060954" cy="1152525"/>
-          </a:xfrm>
-          <a:prstGeom prst="rect">
-            <a:avLst/>
-          </a:prstGeom>
-          <a:noFill/>
-          <a:ln>
-            <a:noFill/>
-          </a:ln>
-        </p:spPr>
-        <p:txBody>
-          <a:bodyPr anchorCtr="0" anchor="t" bIns="25400" lIns="25400" spcFirstLastPara="1" rIns="25400" wrap="square" tIns="25400">
-            <a:noAutofit/>
-          </a:bodyPr>
-          <a:lstStyle/>
-          <a:p>
-            <a:pPr indent="0" lvl="0" marL="0" marR="0" rtl="0" algn="l">
-              <a:lnSpc>
-                <a:spcPct val="108333"/>
-              </a:lnSpc>
-              <a:spcBef>
-                <a:spcPts val="0"/>
-              </a:spcBef>
-              <a:spcAft>
-                <a:spcPts val="0"/>
-              </a:spcAft>
-              <a:buClr>
-                <a:srgbClr val="4A4A4A"/>
-              </a:buClr>
-              <a:buSzPts val="1950"/>
-              <a:buFont typeface="Manrope"/>
-              <a:buNone/>
-            </a:pPr>
-            <a:r>
-              <a:rPr b="0" i="0" lang="en-US" sz="1950" u="none" cap="none" strike="noStrike">
-                <a:solidFill>
-                  <a:srgbClr val="4A4A4A"/>
-                </a:solidFill>
-                <a:latin typeface="Manrope"/>
-                <a:ea typeface="Manrope"/>
-                <a:cs typeface="Manrope"/>
-                <a:sym typeface="Manrope"/>
-              </a:rPr>
-              <a:t>Escenario más desafiante: la atención se pone a prueba.</a:t>
-            </a:r>
-            <a:endParaRPr b="0" i="0" sz="1950" u="none" cap="none" strike="noStrike">
-              <a:solidFill>
-                <a:schemeClr val="dk1"/>
-              </a:solidFill>
-              <a:latin typeface="Calibri"/>
-              <a:ea typeface="Calibri"/>
-              <a:cs typeface="Calibri"/>
-              <a:sym typeface="Calibri"/>
-            </a:endParaRPr>
-          </a:p>
-        </p:txBody>
-      </p:sp>
-      <p:sp>
-        <p:nvSpPr>
-          <p:cNvPr id="96" name="Google Shape;96;p6"/>
+          <p:cNvPr id="94" name="Google Shape;94;p6"/>
           <p:cNvSpPr/>
           <p:nvPr/>
         </p:nvSpPr>
@@ -8243,7 +8097,7 @@
       </p:sp>
       <p:sp>
         <p:nvSpPr>
-          <p:cNvPr id="97" name="Google Shape;97;p6"/>
+          <p:cNvPr id="95" name="Google Shape;95;p6"/>
           <p:cNvSpPr/>
           <p:nvPr/>
         </p:nvSpPr>
@@ -8306,14 +8160,14 @@
       </p:sp>
       <p:sp>
         <p:nvSpPr>
-          <p:cNvPr id="98" name="Google Shape;98;p6"/>
+          <p:cNvPr id="96" name="Google Shape;96;p6"/>
           <p:cNvSpPr/>
           <p:nvPr/>
         </p:nvSpPr>
         <p:spPr>
           <a:xfrm>
             <a:off x="11010900" y="6138994"/>
-            <a:ext cx="3268980" cy="415230"/>
+            <a:ext cx="3269100" cy="415200"/>
           </a:xfrm>
           <a:prstGeom prst="rect">
             <a:avLst/>
@@ -8372,73 +8226,7 @@
       </p:sp>
       <p:sp>
         <p:nvSpPr>
-          <p:cNvPr id="99" name="Google Shape;99;p6"/>
-          <p:cNvSpPr/>
-          <p:nvPr/>
-        </p:nvSpPr>
-        <p:spPr>
-          <a:xfrm>
-            <a:off x="11010900" y="6706624"/>
-            <a:ext cx="3060954" cy="781050"/>
-          </a:xfrm>
-          <a:prstGeom prst="rect">
-            <a:avLst/>
-          </a:prstGeom>
-          <a:noFill/>
-          <a:ln>
-            <a:noFill/>
-          </a:ln>
-        </p:spPr>
-        <p:txBody>
-          <a:bodyPr anchorCtr="0" anchor="t" bIns="25400" lIns="25400" spcFirstLastPara="1" rIns="25400" wrap="square" tIns="25400">
-            <a:noAutofit/>
-          </a:bodyPr>
-          <a:lstStyle/>
-          <a:p>
-            <a:pPr indent="0" lvl="0" marL="0" marR="0" rtl="0" algn="l">
-              <a:lnSpc>
-                <a:spcPct val="108333"/>
-              </a:lnSpc>
-              <a:spcBef>
-                <a:spcPts val="0"/>
-              </a:spcBef>
-              <a:spcAft>
-                <a:spcPts val="0"/>
-              </a:spcAft>
-              <a:buClr>
-                <a:srgbClr val="4A4A4A"/>
-              </a:buClr>
-              <a:buSzPts val="1950"/>
-              <a:buFont typeface="Manrope"/>
-              <a:buNone/>
-            </a:pPr>
-            <a:r>
-              <a:rPr b="0" i="0" lang="en-US" sz="1950" u="none" cap="none" strike="noStrike">
-                <a:solidFill>
-                  <a:srgbClr val="4A4A4A"/>
-                </a:solidFill>
-                <a:latin typeface="Manrope"/>
-                <a:ea typeface="Manrope"/>
-                <a:cs typeface="Manrope"/>
-                <a:sym typeface="Manrope"/>
-              </a:rPr>
-              <a:t>Interacción para volver a la calma.</a:t>
-            </a:r>
-            <a:endParaRPr b="0" i="0" sz="1950" u="none" cap="none" strike="noStrike">
-              <a:solidFill>
-                <a:schemeClr val="dk1"/>
-              </a:solidFill>
-              <a:latin typeface="Calibri"/>
-              <a:ea typeface="Calibri"/>
-              <a:cs typeface="Calibri"/>
-              <a:sym typeface="Calibri"/>
-            </a:endParaRPr>
-          </a:p>
-        </p:txBody>
-      </p:sp>
-      <p:sp>
-        <p:nvSpPr>
-          <p:cNvPr id="100" name="Google Shape;100;p6"/>
+          <p:cNvPr id="97" name="Google Shape;97;p6"/>
           <p:cNvSpPr/>
           <p:nvPr/>
         </p:nvSpPr>
@@ -8483,7 +8271,7 @@
       </p:sp>
       <p:sp>
         <p:nvSpPr>
-          <p:cNvPr id="101" name="Google Shape;101;p6"/>
+          <p:cNvPr id="98" name="Google Shape;98;p6"/>
           <p:cNvSpPr/>
           <p:nvPr/>
         </p:nvSpPr>
@@ -8546,14 +8334,14 @@
       </p:sp>
       <p:sp>
         <p:nvSpPr>
-          <p:cNvPr id="102" name="Google Shape;102;p6"/>
+          <p:cNvPr id="99" name="Google Shape;99;p6"/>
           <p:cNvSpPr/>
           <p:nvPr/>
         </p:nvSpPr>
         <p:spPr>
           <a:xfrm>
             <a:off x="14363700" y="6138994"/>
-            <a:ext cx="3268980" cy="415230"/>
+            <a:ext cx="3269100" cy="415200"/>
           </a:xfrm>
           <a:prstGeom prst="rect">
             <a:avLst/>
@@ -8612,73 +8400,7 @@
       </p:sp>
       <p:sp>
         <p:nvSpPr>
-          <p:cNvPr id="103" name="Google Shape;103;p6"/>
-          <p:cNvSpPr/>
-          <p:nvPr/>
-        </p:nvSpPr>
-        <p:spPr>
-          <a:xfrm>
-            <a:off x="14363700" y="6706624"/>
-            <a:ext cx="3060954" cy="781050"/>
-          </a:xfrm>
-          <a:prstGeom prst="rect">
-            <a:avLst/>
-          </a:prstGeom>
-          <a:noFill/>
-          <a:ln>
-            <a:noFill/>
-          </a:ln>
-        </p:spPr>
-        <p:txBody>
-          <a:bodyPr anchorCtr="0" anchor="t" bIns="25400" lIns="25400" spcFirstLastPara="1" rIns="25400" wrap="square" tIns="25400">
-            <a:noAutofit/>
-          </a:bodyPr>
-          <a:lstStyle/>
-          <a:p>
-            <a:pPr indent="0" lvl="0" marL="0" marR="0" rtl="0" algn="l">
-              <a:lnSpc>
-                <a:spcPct val="108333"/>
-              </a:lnSpc>
-              <a:spcBef>
-                <a:spcPts val="0"/>
-              </a:spcBef>
-              <a:spcAft>
-                <a:spcPts val="0"/>
-              </a:spcAft>
-              <a:buClr>
-                <a:srgbClr val="4A4A4A"/>
-              </a:buClr>
-              <a:buSzPts val="1950"/>
-              <a:buFont typeface="Manrope"/>
-              <a:buNone/>
-            </a:pPr>
-            <a:r>
-              <a:rPr b="0" i="0" lang="en-US" sz="1950" u="none" cap="none" strike="noStrike">
-                <a:solidFill>
-                  <a:srgbClr val="4A4A4A"/>
-                </a:solidFill>
-                <a:latin typeface="Manrope"/>
-                <a:ea typeface="Manrope"/>
-                <a:cs typeface="Manrope"/>
-                <a:sym typeface="Manrope"/>
-              </a:rPr>
-              <a:t>Permite comparar el antes y el después.</a:t>
-            </a:r>
-            <a:endParaRPr b="0" i="0" sz="1950" u="none" cap="none" strike="noStrike">
-              <a:solidFill>
-                <a:schemeClr val="dk1"/>
-              </a:solidFill>
-              <a:latin typeface="Calibri"/>
-              <a:ea typeface="Calibri"/>
-              <a:cs typeface="Calibri"/>
-              <a:sym typeface="Calibri"/>
-            </a:endParaRPr>
-          </a:p>
-        </p:txBody>
-      </p:sp>
-      <p:sp>
-        <p:nvSpPr>
-          <p:cNvPr id="104" name="Google Shape;104;p6"/>
+          <p:cNvPr id="100" name="Google Shape;100;p6"/>
           <p:cNvSpPr/>
           <p:nvPr/>
         </p:nvSpPr>
@@ -8723,7 +8445,7 @@
       </p:sp>
       <p:sp>
         <p:nvSpPr>
-          <p:cNvPr id="105" name="Google Shape;105;p6"/>
+          <p:cNvPr id="101" name="Google Shape;101;p6"/>
           <p:cNvSpPr/>
           <p:nvPr/>
         </p:nvSpPr>
@@ -8768,7 +8490,7 @@
       </p:sp>
       <p:sp>
         <p:nvSpPr>
-          <p:cNvPr id="106" name="Google Shape;106;p6"/>
+          <p:cNvPr id="102" name="Google Shape;102;p6"/>
           <p:cNvSpPr/>
           <p:nvPr/>
         </p:nvSpPr>
@@ -8834,7 +8556,7 @@
       </p:sp>
       <p:sp>
         <p:nvSpPr>
-          <p:cNvPr id="107" name="Google Shape;107;p6"/>
+          <p:cNvPr id="103" name="Google Shape;103;p6"/>
           <p:cNvSpPr/>
           <p:nvPr/>
         </p:nvSpPr>
@@ -8897,7 +8619,7 @@
       </p:sp>
       <p:sp>
         <p:nvSpPr>
-          <p:cNvPr id="108" name="Google Shape;108;p6"/>
+          <p:cNvPr id="104" name="Google Shape;104;p6"/>
           <p:cNvSpPr/>
           <p:nvPr/>
         </p:nvSpPr>
@@ -8958,6 +8680,34 @@
           </a:p>
         </p:txBody>
       </p:sp>
+      <p:pic>
+        <p:nvPicPr>
+          <p:cNvPr id="105" name="Google Shape;105;p6"/>
+          <p:cNvPicPr preferRelativeResize="0"/>
+          <p:nvPr/>
+        </p:nvPicPr>
+        <p:blipFill>
+          <a:blip r:embed="rId3">
+            <a:alphaModFix/>
+          </a:blip>
+          <a:stretch>
+            <a:fillRect/>
+          </a:stretch>
+        </p:blipFill>
+        <p:spPr>
+          <a:xfrm>
+            <a:off x="14071850" y="266425"/>
+            <a:ext cx="3269100" cy="3269100"/>
+          </a:xfrm>
+          <a:prstGeom prst="ellipse">
+            <a:avLst/>
+          </a:prstGeom>
+          <a:noFill/>
+          <a:ln>
+            <a:noFill/>
+          </a:ln>
+        </p:spPr>
+      </p:pic>
     </p:spTree>
   </p:cSld>
   <p:clrMapOvr>
@@ -8978,7 +8728,7 @@
     </p:bg>
     <p:spTree>
       <p:nvGrpSpPr>
-        <p:cNvPr id="113" name="Shape 113"/>
+        <p:cNvPr id="110" name="Shape 110"/>
         <p:cNvGrpSpPr/>
         <p:nvPr/>
       </p:nvGrpSpPr>
@@ -8992,7 +8742,7 @@
       </p:grpSpPr>
       <p:sp>
         <p:nvSpPr>
-          <p:cNvPr id="114" name="Google Shape;114;p7"/>
+          <p:cNvPr id="111" name="Google Shape;111;p7"/>
           <p:cNvSpPr/>
           <p:nvPr/>
         </p:nvSpPr>
@@ -9055,7 +8805,7 @@
       </p:sp>
       <p:sp>
         <p:nvSpPr>
-          <p:cNvPr id="115" name="Google Shape;115;p7"/>
+          <p:cNvPr id="112" name="Google Shape;112;p7"/>
           <p:cNvSpPr/>
           <p:nvPr/>
         </p:nvSpPr>
@@ -9100,7 +8850,7 @@
       </p:sp>
       <p:sp>
         <p:nvSpPr>
-          <p:cNvPr id="116" name="Google Shape;116;p7"/>
+          <p:cNvPr id="113" name="Google Shape;113;p7"/>
           <p:cNvSpPr/>
           <p:nvPr/>
         </p:nvSpPr>
@@ -9163,14 +8913,14 @@
       </p:sp>
       <p:sp>
         <p:nvSpPr>
-          <p:cNvPr id="117" name="Google Shape;117;p7"/>
-          <p:cNvSpPr/>
-          <p:nvPr/>
-        </p:nvSpPr>
-        <p:spPr>
-          <a:xfrm>
-            <a:off x="952500" y="1629438"/>
-            <a:ext cx="16383000" cy="3122811"/>
+          <p:cNvPr id="114" name="Google Shape;114;p7"/>
+          <p:cNvSpPr/>
+          <p:nvPr/>
+        </p:nvSpPr>
+        <p:spPr>
+          <a:xfrm>
+            <a:off x="952500" y="3012888"/>
+            <a:ext cx="16383000" cy="3122700"/>
           </a:xfrm>
           <a:prstGeom prst="rect">
             <a:avLst/>
@@ -9208,14 +8958,14 @@
       </p:sp>
       <p:sp>
         <p:nvSpPr>
-          <p:cNvPr id="118" name="Google Shape;118;p7"/>
-          <p:cNvSpPr/>
-          <p:nvPr/>
-        </p:nvSpPr>
-        <p:spPr>
-          <a:xfrm>
-            <a:off x="952500" y="1629438"/>
-            <a:ext cx="38100" cy="3122811"/>
+          <p:cNvPr id="115" name="Google Shape;115;p7"/>
+          <p:cNvSpPr/>
+          <p:nvPr/>
+        </p:nvSpPr>
+        <p:spPr>
+          <a:xfrm>
+            <a:off x="990600" y="2990288"/>
+            <a:ext cx="38100" cy="3122700"/>
           </a:xfrm>
           <a:prstGeom prst="rect">
             <a:avLst/>
@@ -9253,14 +9003,14 @@
       </p:sp>
       <p:sp>
         <p:nvSpPr>
-          <p:cNvPr id="119" name="Google Shape;119;p7"/>
-          <p:cNvSpPr/>
-          <p:nvPr/>
-        </p:nvSpPr>
-        <p:spPr>
-          <a:xfrm>
-            <a:off x="1485900" y="2048538"/>
-            <a:ext cx="3458885" cy="349250"/>
+          <p:cNvPr id="116" name="Google Shape;116;p7"/>
+          <p:cNvSpPr/>
+          <p:nvPr/>
+        </p:nvSpPr>
+        <p:spPr>
+          <a:xfrm>
+            <a:off x="1485900" y="3241438"/>
+            <a:ext cx="3459000" cy="349200"/>
           </a:xfrm>
           <a:prstGeom prst="rect">
             <a:avLst/>
@@ -9316,14 +9066,14 @@
       </p:sp>
       <p:sp>
         <p:nvSpPr>
-          <p:cNvPr id="120" name="Google Shape;120;p7"/>
-          <p:cNvSpPr/>
-          <p:nvPr/>
-        </p:nvSpPr>
-        <p:spPr>
-          <a:xfrm>
-            <a:off x="1485900" y="2550189"/>
-            <a:ext cx="15814929" cy="1821061"/>
+          <p:cNvPr id="117" name="Google Shape;117;p7"/>
+          <p:cNvSpPr/>
+          <p:nvPr/>
+        </p:nvSpPr>
+        <p:spPr>
+          <a:xfrm>
+            <a:off x="1485900" y="3743089"/>
+            <a:ext cx="15814800" cy="1821000"/>
           </a:xfrm>
           <a:prstGeom prst="rect">
             <a:avLst/>
@@ -9382,14 +9132,14 @@
       </p:sp>
       <p:sp>
         <p:nvSpPr>
-          <p:cNvPr id="121" name="Google Shape;121;p7"/>
-          <p:cNvSpPr/>
-          <p:nvPr/>
-        </p:nvSpPr>
-        <p:spPr>
-          <a:xfrm>
-            <a:off x="952500" y="5323749"/>
-            <a:ext cx="4159568" cy="349250"/>
+          <p:cNvPr id="118" name="Google Shape;118;p7"/>
+          <p:cNvSpPr/>
+          <p:nvPr/>
+        </p:nvSpPr>
+        <p:spPr>
+          <a:xfrm>
+            <a:off x="952500" y="6227487"/>
+            <a:ext cx="4159500" cy="349200"/>
           </a:xfrm>
           <a:prstGeom prst="rect">
             <a:avLst/>
@@ -9445,14 +9195,14 @@
       </p:sp>
       <p:sp>
         <p:nvSpPr>
-          <p:cNvPr id="122" name="Google Shape;122;p7"/>
-          <p:cNvSpPr/>
-          <p:nvPr/>
-        </p:nvSpPr>
-        <p:spPr>
-          <a:xfrm>
-            <a:off x="952500" y="5787300"/>
-            <a:ext cx="3435689" cy="19050"/>
+          <p:cNvPr id="119" name="Google Shape;119;p7"/>
+          <p:cNvSpPr/>
+          <p:nvPr/>
+        </p:nvSpPr>
+        <p:spPr>
+          <a:xfrm>
+            <a:off x="952500" y="6691038"/>
+            <a:ext cx="3435600" cy="19200"/>
           </a:xfrm>
           <a:prstGeom prst="rect">
             <a:avLst/>
@@ -9490,14 +9240,14 @@
       </p:sp>
       <p:sp>
         <p:nvSpPr>
-          <p:cNvPr id="123" name="Google Shape;123;p7"/>
-          <p:cNvSpPr/>
-          <p:nvPr/>
-        </p:nvSpPr>
-        <p:spPr>
-          <a:xfrm>
-            <a:off x="952500" y="6034950"/>
-            <a:ext cx="4159568" cy="419100"/>
+          <p:cNvPr id="120" name="Google Shape;120;p7"/>
+          <p:cNvSpPr/>
+          <p:nvPr/>
+        </p:nvSpPr>
+        <p:spPr>
+          <a:xfrm>
+            <a:off x="952500" y="6938688"/>
+            <a:ext cx="4159500" cy="419100"/>
           </a:xfrm>
           <a:prstGeom prst="rect">
             <a:avLst/>
@@ -9556,14 +9306,14 @@
       </p:sp>
       <p:sp>
         <p:nvSpPr>
-          <p:cNvPr id="124" name="Google Shape;124;p7"/>
-          <p:cNvSpPr/>
-          <p:nvPr/>
-        </p:nvSpPr>
-        <p:spPr>
-          <a:xfrm>
-            <a:off x="952500" y="6568350"/>
-            <a:ext cx="3894868" cy="781050"/>
+          <p:cNvPr id="121" name="Google Shape;121;p7"/>
+          <p:cNvSpPr/>
+          <p:nvPr/>
+        </p:nvSpPr>
+        <p:spPr>
+          <a:xfrm>
+            <a:off x="5153025" y="6227487"/>
+            <a:ext cx="4159500" cy="349200"/>
           </a:xfrm>
           <a:prstGeom prst="rect">
             <a:avLst/>
@@ -9580,9 +9330,6 @@
           <a:lstStyle/>
           <a:p>
             <a:pPr indent="0" lvl="0" marL="0" marR="0" rtl="0" algn="l">
-              <a:lnSpc>
-                <a:spcPct val="108333"/>
-              </a:lnSpc>
               <a:spcBef>
                 <a:spcPts val="0"/>
               </a:spcBef>
@@ -9590,89 +9337,23 @@
                 <a:spcPts val="0"/>
               </a:spcAft>
               <a:buClr>
-                <a:srgbClr val="4A4A4A"/>
+                <a:srgbClr val="B07F96"/>
               </a:buClr>
-              <a:buSzPts val="1950"/>
+              <a:buSzPts val="1800"/>
               <a:buFont typeface="Manrope"/>
               <a:buNone/>
             </a:pPr>
             <a:r>
-              <a:rPr b="0" i="0" lang="en-US" sz="1950" u="none" cap="none" strike="noStrike">
-                <a:solidFill>
-                  <a:srgbClr val="4A4A4A"/>
+              <a:rPr b="1" i="0" lang="en-US" sz="1800" u="none" cap="none" strike="noStrike">
+                <a:solidFill>
+                  <a:srgbClr val="B07F96"/>
                 </a:solidFill>
                 <a:latin typeface="Manrope"/>
                 <a:ea typeface="Manrope"/>
                 <a:cs typeface="Manrope"/>
                 <a:sym typeface="Manrope"/>
               </a:rPr>
-              <a:t>Cinco escenarios de exigencia creciente.</a:t>
-            </a:r>
-            <a:endParaRPr b="0" i="0" sz="1950" u="none" cap="none" strike="noStrike">
-              <a:solidFill>
-                <a:schemeClr val="dk1"/>
-              </a:solidFill>
-              <a:latin typeface="Calibri"/>
-              <a:ea typeface="Calibri"/>
-              <a:cs typeface="Calibri"/>
-              <a:sym typeface="Calibri"/>
-            </a:endParaRPr>
-          </a:p>
-        </p:txBody>
-      </p:sp>
-      <p:sp>
-        <p:nvSpPr>
-          <p:cNvPr id="125" name="Google Shape;125;p7"/>
-          <p:cNvSpPr/>
-          <p:nvPr/>
-        </p:nvSpPr>
-        <p:spPr>
-          <a:xfrm>
-            <a:off x="952500" y="7463700"/>
-            <a:ext cx="3894868" cy="700881"/>
-          </a:xfrm>
-          <a:prstGeom prst="rect">
-            <a:avLst/>
-          </a:prstGeom>
-          <a:noFill/>
-          <a:ln>
-            <a:noFill/>
-          </a:ln>
-        </p:spPr>
-        <p:txBody>
-          <a:bodyPr anchorCtr="0" anchor="t" bIns="25400" lIns="25400" spcFirstLastPara="1" rIns="25400" wrap="square" tIns="25400">
-            <a:noAutofit/>
-          </a:bodyPr>
-          <a:lstStyle/>
-          <a:p>
-            <a:pPr indent="0" lvl="0" marL="0" marR="0" rtl="0" algn="l">
-              <a:lnSpc>
-                <a:spcPct val="106531"/>
-              </a:lnSpc>
-              <a:spcBef>
-                <a:spcPts val="0"/>
-              </a:spcBef>
-              <a:spcAft>
-                <a:spcPts val="0"/>
-              </a:spcAft>
-              <a:buClr>
-                <a:srgbClr val="6B5B64"/>
-              </a:buClr>
-              <a:buSzPts val="1800"/>
-              <a:buFont typeface="Manrope"/>
-              <a:buNone/>
-            </a:pPr>
-            <a:r>
-              <a:rPr b="0" i="1" lang="en-US" sz="1800" u="none" cap="none" strike="noStrike">
-                <a:solidFill>
-                  <a:srgbClr val="6B5B64"/>
-                </a:solidFill>
-                <a:latin typeface="Manrope"/>
-                <a:ea typeface="Manrope"/>
-                <a:cs typeface="Manrope"/>
-                <a:sym typeface="Manrope"/>
-              </a:rPr>
-              <a:t>Cómo: assets y builds probados en visor.</a:t>
+              <a:t>O2</a:t>
             </a:r>
             <a:endParaRPr b="0" i="0" sz="1800" u="none" cap="none" strike="noStrike">
               <a:solidFill>
@@ -9688,14 +9369,125 @@
       </p:sp>
       <p:sp>
         <p:nvSpPr>
-          <p:cNvPr id="126" name="Google Shape;126;p7"/>
-          <p:cNvSpPr/>
-          <p:nvPr/>
-        </p:nvSpPr>
-        <p:spPr>
-          <a:xfrm>
-            <a:off x="5153025" y="5323749"/>
-            <a:ext cx="4159568" cy="349250"/>
+          <p:cNvPr id="122" name="Google Shape;122;p7"/>
+          <p:cNvSpPr/>
+          <p:nvPr/>
+        </p:nvSpPr>
+        <p:spPr>
+          <a:xfrm>
+            <a:off x="5153025" y="6691038"/>
+            <a:ext cx="3435600" cy="19200"/>
+          </a:xfrm>
+          <a:prstGeom prst="rect">
+            <a:avLst/>
+          </a:prstGeom>
+          <a:solidFill>
+            <a:srgbClr val="C594AA">
+              <a:alpha val="96078"/>
+            </a:srgbClr>
+          </a:solidFill>
+          <a:ln>
+            <a:noFill/>
+          </a:ln>
+        </p:spPr>
+        <p:txBody>
+          <a:bodyPr anchorCtr="0" anchor="ctr" bIns="91425" lIns="91425" spcFirstLastPara="1" rIns="91425" wrap="square" tIns="91425">
+            <a:noAutofit/>
+          </a:bodyPr>
+          <a:lstStyle/>
+          <a:p>
+            <a:pPr indent="0" lvl="0" marL="0" rtl="0" algn="l">
+              <a:spcBef>
+                <a:spcPts val="0"/>
+              </a:spcBef>
+              <a:spcAft>
+                <a:spcPts val="0"/>
+              </a:spcAft>
+              <a:buNone/>
+            </a:pPr>
+            <a:r>
+              <a:t/>
+            </a:r>
+            <a:endParaRPr/>
+          </a:p>
+        </p:txBody>
+      </p:sp>
+      <p:sp>
+        <p:nvSpPr>
+          <p:cNvPr id="123" name="Google Shape;123;p7"/>
+          <p:cNvSpPr/>
+          <p:nvPr/>
+        </p:nvSpPr>
+        <p:spPr>
+          <a:xfrm>
+            <a:off x="5153025" y="6938688"/>
+            <a:ext cx="3894900" cy="800100"/>
+          </a:xfrm>
+          <a:prstGeom prst="rect">
+            <a:avLst/>
+          </a:prstGeom>
+          <a:noFill/>
+          <a:ln>
+            <a:noFill/>
+          </a:ln>
+        </p:spPr>
+        <p:txBody>
+          <a:bodyPr anchorCtr="0" anchor="t" bIns="25400" lIns="25400" spcFirstLastPara="1" rIns="25400" wrap="square" tIns="25400">
+            <a:noAutofit/>
+          </a:bodyPr>
+          <a:lstStyle/>
+          <a:p>
+            <a:pPr indent="0" lvl="0" marL="0" marR="0" rtl="0" algn="l">
+              <a:lnSpc>
+                <a:spcPct val="92308"/>
+              </a:lnSpc>
+              <a:spcBef>
+                <a:spcPts val="0"/>
+              </a:spcBef>
+              <a:spcAft>
+                <a:spcPts val="0"/>
+              </a:spcAft>
+              <a:buClr>
+                <a:srgbClr val="0F3460"/>
+              </a:buClr>
+              <a:buSzPts val="2400"/>
+              <a:buFont typeface="Manrope"/>
+              <a:buNone/>
+            </a:pPr>
+            <a:r>
+              <a:rPr b="1" i="0" lang="en-US" sz="2400" u="none" cap="none" strike="noStrike">
+                <a:solidFill>
+                  <a:srgbClr val="0F3460"/>
+                </a:solidFill>
+                <a:latin typeface="Manrope"/>
+                <a:ea typeface="Manrope"/>
+                <a:cs typeface="Manrope"/>
+                <a:sym typeface="Manrope"/>
+              </a:rPr>
+              <a:t>Construir la arquitectura de datos</a:t>
+            </a:r>
+            <a:endParaRPr b="0" i="0" sz="2400" u="none" cap="none" strike="noStrike">
+              <a:solidFill>
+                <a:schemeClr val="dk1"/>
+              </a:solidFill>
+              <a:latin typeface="Calibri"/>
+              <a:ea typeface="Calibri"/>
+              <a:cs typeface="Calibri"/>
+              <a:sym typeface="Calibri"/>
+            </a:endParaRPr>
+          </a:p>
+        </p:txBody>
+      </p:sp>
+      <p:sp>
+        <p:nvSpPr>
+          <p:cNvPr id="124" name="Google Shape;124;p7"/>
+          <p:cNvSpPr/>
+          <p:nvPr/>
+        </p:nvSpPr>
+        <p:spPr>
+          <a:xfrm>
+            <a:off x="9353550" y="6227487"/>
+            <a:ext cx="4159500" cy="349200"/>
           </a:xfrm>
           <a:prstGeom prst="rect">
             <a:avLst/>
@@ -9735,7 +9527,7 @@
                 <a:cs typeface="Manrope"/>
                 <a:sym typeface="Manrope"/>
               </a:rPr>
-              <a:t>O2</a:t>
+              <a:t>O3</a:t>
             </a:r>
             <a:endParaRPr b="0" i="0" sz="1800" u="none" cap="none" strike="noStrike">
               <a:solidFill>
@@ -9751,14 +9543,14 @@
       </p:sp>
       <p:sp>
         <p:nvSpPr>
-          <p:cNvPr id="127" name="Google Shape;127;p7"/>
-          <p:cNvSpPr/>
-          <p:nvPr/>
-        </p:nvSpPr>
-        <p:spPr>
-          <a:xfrm>
-            <a:off x="5153025" y="5787300"/>
-            <a:ext cx="3435688" cy="19050"/>
+          <p:cNvPr id="125" name="Google Shape;125;p7"/>
+          <p:cNvSpPr/>
+          <p:nvPr/>
+        </p:nvSpPr>
+        <p:spPr>
+          <a:xfrm>
+            <a:off x="9353550" y="6691038"/>
+            <a:ext cx="3435600" cy="19200"/>
           </a:xfrm>
           <a:prstGeom prst="rect">
             <a:avLst/>
@@ -9796,14 +9588,14 @@
       </p:sp>
       <p:sp>
         <p:nvSpPr>
-          <p:cNvPr id="128" name="Google Shape;128;p7"/>
-          <p:cNvSpPr/>
-          <p:nvPr/>
-        </p:nvSpPr>
-        <p:spPr>
-          <a:xfrm>
-            <a:off x="5153025" y="6034950"/>
-            <a:ext cx="3894868" cy="800100"/>
+          <p:cNvPr id="126" name="Google Shape;126;p7"/>
+          <p:cNvSpPr/>
+          <p:nvPr/>
+        </p:nvSpPr>
+        <p:spPr>
+          <a:xfrm>
+            <a:off x="9353550" y="6938688"/>
+            <a:ext cx="3894900" cy="800100"/>
           </a:xfrm>
           <a:prstGeom prst="rect">
             <a:avLst/>
@@ -9846,7 +9638,7 @@
                 <a:cs typeface="Manrope"/>
                 <a:sym typeface="Manrope"/>
               </a:rPr>
-              <a:t>Construir la arquitectura de datos</a:t>
+              <a:t>Ejecutar las pruebas de campo</a:t>
             </a:r>
             <a:endParaRPr b="0" i="0" sz="2400" u="none" cap="none" strike="noStrike">
               <a:solidFill>
@@ -9862,14 +9654,14 @@
       </p:sp>
       <p:sp>
         <p:nvSpPr>
-          <p:cNvPr id="129" name="Google Shape;129;p7"/>
-          <p:cNvSpPr/>
-          <p:nvPr/>
-        </p:nvSpPr>
-        <p:spPr>
-          <a:xfrm>
-            <a:off x="5153025" y="6949350"/>
-            <a:ext cx="3894868" cy="781050"/>
+          <p:cNvPr id="127" name="Google Shape;127;p7"/>
+          <p:cNvSpPr/>
+          <p:nvPr/>
+        </p:nvSpPr>
+        <p:spPr>
+          <a:xfrm>
+            <a:off x="13554075" y="6227487"/>
+            <a:ext cx="4159500" cy="349200"/>
           </a:xfrm>
           <a:prstGeom prst="rect">
             <a:avLst/>
@@ -9886,9 +9678,6 @@
           <a:lstStyle/>
           <a:p>
             <a:pPr indent="0" lvl="0" marL="0" marR="0" rtl="0" algn="l">
-              <a:lnSpc>
-                <a:spcPct val="108333"/>
-              </a:lnSpc>
               <a:spcBef>
                 <a:spcPts val="0"/>
               </a:spcBef>
@@ -9896,89 +9685,23 @@
                 <a:spcPts val="0"/>
               </a:spcAft>
               <a:buClr>
-                <a:srgbClr val="4A4A4A"/>
+                <a:srgbClr val="B07F96"/>
               </a:buClr>
-              <a:buSzPts val="1950"/>
+              <a:buSzPts val="1800"/>
               <a:buFont typeface="Manrope"/>
               <a:buNone/>
             </a:pPr>
             <a:r>
-              <a:rPr b="0" i="0" lang="en-US" sz="1950" u="none" cap="none" strike="noStrike">
-                <a:solidFill>
-                  <a:srgbClr val="4A4A4A"/>
+              <a:rPr b="1" i="0" lang="en-US" sz="1800" u="none" cap="none" strike="noStrike">
+                <a:solidFill>
+                  <a:srgbClr val="B07F96"/>
                 </a:solidFill>
                 <a:latin typeface="Manrope"/>
                 <a:ea typeface="Manrope"/>
                 <a:cs typeface="Manrope"/>
                 <a:sym typeface="Manrope"/>
               </a:rPr>
-              <a:t>Captura del recorrido y transmisión vía AWS.</a:t>
-            </a:r>
-            <a:endParaRPr b="0" i="0" sz="1950" u="none" cap="none" strike="noStrike">
-              <a:solidFill>
-                <a:schemeClr val="dk1"/>
-              </a:solidFill>
-              <a:latin typeface="Calibri"/>
-              <a:ea typeface="Calibri"/>
-              <a:cs typeface="Calibri"/>
-              <a:sym typeface="Calibri"/>
-            </a:endParaRPr>
-          </a:p>
-        </p:txBody>
-      </p:sp>
-      <p:sp>
-        <p:nvSpPr>
-          <p:cNvPr id="130" name="Google Shape;130;p7"/>
-          <p:cNvSpPr/>
-          <p:nvPr/>
-        </p:nvSpPr>
-        <p:spPr>
-          <a:xfrm>
-            <a:off x="5153025" y="7844700"/>
-            <a:ext cx="3894868" cy="700881"/>
-          </a:xfrm>
-          <a:prstGeom prst="rect">
-            <a:avLst/>
-          </a:prstGeom>
-          <a:noFill/>
-          <a:ln>
-            <a:noFill/>
-          </a:ln>
-        </p:spPr>
-        <p:txBody>
-          <a:bodyPr anchorCtr="0" anchor="t" bIns="25400" lIns="25400" spcFirstLastPara="1" rIns="25400" wrap="square" tIns="25400">
-            <a:noAutofit/>
-          </a:bodyPr>
-          <a:lstStyle/>
-          <a:p>
-            <a:pPr indent="0" lvl="0" marL="0" marR="0" rtl="0" algn="l">
-              <a:lnSpc>
-                <a:spcPct val="106531"/>
-              </a:lnSpc>
-              <a:spcBef>
-                <a:spcPts val="0"/>
-              </a:spcBef>
-              <a:spcAft>
-                <a:spcPts val="0"/>
-              </a:spcAft>
-              <a:buClr>
-                <a:srgbClr val="6B5B64"/>
-              </a:buClr>
-              <a:buSzPts val="1800"/>
-              <a:buFont typeface="Manrope"/>
-              <a:buNone/>
-            </a:pPr>
-            <a:r>
-              <a:rPr b="0" i="1" lang="en-US" sz="1800" u="none" cap="none" strike="noStrike">
-                <a:solidFill>
-                  <a:srgbClr val="6B5B64"/>
-                </a:solidFill>
-                <a:latin typeface="Manrope"/>
-                <a:ea typeface="Manrope"/>
-                <a:cs typeface="Manrope"/>
-                <a:sym typeface="Manrope"/>
-              </a:rPr>
-              <a:t>Cómo: integración con el servidor en la nube.</a:t>
+              <a:t>O4</a:t>
             </a:r>
             <a:endParaRPr b="0" i="0" sz="1800" u="none" cap="none" strike="noStrike">
               <a:solidFill>
@@ -9994,14 +9717,59 @@
       </p:sp>
       <p:sp>
         <p:nvSpPr>
-          <p:cNvPr id="131" name="Google Shape;131;p7"/>
-          <p:cNvSpPr/>
-          <p:nvPr/>
-        </p:nvSpPr>
-        <p:spPr>
-          <a:xfrm>
-            <a:off x="9353550" y="5323749"/>
-            <a:ext cx="4159568" cy="349250"/>
+          <p:cNvPr id="128" name="Google Shape;128;p7"/>
+          <p:cNvSpPr/>
+          <p:nvPr/>
+        </p:nvSpPr>
+        <p:spPr>
+          <a:xfrm>
+            <a:off x="13554075" y="6691038"/>
+            <a:ext cx="3435600" cy="19200"/>
+          </a:xfrm>
+          <a:prstGeom prst="rect">
+            <a:avLst/>
+          </a:prstGeom>
+          <a:solidFill>
+            <a:srgbClr val="C594AA">
+              <a:alpha val="96078"/>
+            </a:srgbClr>
+          </a:solidFill>
+          <a:ln>
+            <a:noFill/>
+          </a:ln>
+        </p:spPr>
+        <p:txBody>
+          <a:bodyPr anchorCtr="0" anchor="ctr" bIns="91425" lIns="91425" spcFirstLastPara="1" rIns="91425" wrap="square" tIns="91425">
+            <a:noAutofit/>
+          </a:bodyPr>
+          <a:lstStyle/>
+          <a:p>
+            <a:pPr indent="0" lvl="0" marL="0" rtl="0" algn="l">
+              <a:spcBef>
+                <a:spcPts val="0"/>
+              </a:spcBef>
+              <a:spcAft>
+                <a:spcPts val="0"/>
+              </a:spcAft>
+              <a:buNone/>
+            </a:pPr>
+            <a:r>
+              <a:t/>
+            </a:r>
+            <a:endParaRPr/>
+          </a:p>
+        </p:txBody>
+      </p:sp>
+      <p:sp>
+        <p:nvSpPr>
+          <p:cNvPr id="129" name="Google Shape;129;p7"/>
+          <p:cNvSpPr/>
+          <p:nvPr/>
+        </p:nvSpPr>
+        <p:spPr>
+          <a:xfrm>
+            <a:off x="13554075" y="6938688"/>
+            <a:ext cx="3894900" cy="800100"/>
           </a:xfrm>
           <a:prstGeom prst="rect">
             <a:avLst/>
@@ -10018,6 +9786,9 @@
           <a:lstStyle/>
           <a:p>
             <a:pPr indent="0" lvl="0" marL="0" marR="0" rtl="0" algn="l">
+              <a:lnSpc>
+                <a:spcPct val="92308"/>
+              </a:lnSpc>
               <a:spcBef>
                 <a:spcPts val="0"/>
               </a:spcBef>
@@ -10025,23 +9796,257 @@
                 <a:spcPts val="0"/>
               </a:spcAft>
               <a:buClr>
-                <a:srgbClr val="B07F96"/>
+                <a:srgbClr val="0F3460"/>
               </a:buClr>
-              <a:buSzPts val="1800"/>
+              <a:buSzPts val="2400"/>
               <a:buFont typeface="Manrope"/>
               <a:buNone/>
             </a:pPr>
             <a:r>
-              <a:rPr b="1" i="0" lang="en-US" sz="1800" u="none" cap="none" strike="noStrike">
-                <a:solidFill>
-                  <a:srgbClr val="B07F96"/>
+              <a:rPr b="1" i="0" lang="en-US" sz="2400" u="none" cap="none" strike="noStrike">
+                <a:solidFill>
+                  <a:srgbClr val="0F3460"/>
                 </a:solidFill>
                 <a:latin typeface="Manrope"/>
                 <a:ea typeface="Manrope"/>
                 <a:cs typeface="Manrope"/>
                 <a:sym typeface="Manrope"/>
               </a:rPr>
-              <a:t>O3</a:t>
+              <a:t>Proteger la privacidad de los datos</a:t>
+            </a:r>
+            <a:endParaRPr b="0" i="0" sz="2400" u="none" cap="none" strike="noStrike">
+              <a:solidFill>
+                <a:schemeClr val="dk1"/>
+              </a:solidFill>
+              <a:latin typeface="Calibri"/>
+              <a:ea typeface="Calibri"/>
+              <a:cs typeface="Calibri"/>
+              <a:sym typeface="Calibri"/>
+            </a:endParaRPr>
+          </a:p>
+        </p:txBody>
+      </p:sp>
+      <p:sp>
+        <p:nvSpPr>
+          <p:cNvPr id="130" name="Google Shape;130;p7"/>
+          <p:cNvSpPr/>
+          <p:nvPr/>
+        </p:nvSpPr>
+        <p:spPr>
+          <a:xfrm>
+            <a:off x="952500" y="9002781"/>
+            <a:ext cx="16383000" cy="977900"/>
+          </a:xfrm>
+          <a:prstGeom prst="rect">
+            <a:avLst/>
+          </a:prstGeom>
+          <a:solidFill>
+            <a:srgbClr val="0F3460">
+              <a:alpha val="96078"/>
+            </a:srgbClr>
+          </a:solidFill>
+          <a:ln>
+            <a:noFill/>
+          </a:ln>
+        </p:spPr>
+        <p:txBody>
+          <a:bodyPr anchorCtr="0" anchor="ctr" bIns="91425" lIns="91425" spcFirstLastPara="1" rIns="91425" wrap="square" tIns="91425">
+            <a:noAutofit/>
+          </a:bodyPr>
+          <a:lstStyle/>
+          <a:p>
+            <a:pPr indent="0" lvl="0" marL="0" rtl="0" algn="l">
+              <a:spcBef>
+                <a:spcPts val="0"/>
+              </a:spcBef>
+              <a:spcAft>
+                <a:spcPts val="0"/>
+              </a:spcAft>
+              <a:buNone/>
+            </a:pPr>
+            <a:r>
+              <a:t/>
+            </a:r>
+            <a:endParaRPr/>
+          </a:p>
+        </p:txBody>
+      </p:sp>
+      <p:sp>
+        <p:nvSpPr>
+          <p:cNvPr id="131" name="Google Shape;131;p7"/>
+          <p:cNvSpPr/>
+          <p:nvPr/>
+        </p:nvSpPr>
+        <p:spPr>
+          <a:xfrm>
+            <a:off x="1790402" y="9288531"/>
+            <a:ext cx="6297196" cy="444500"/>
+          </a:xfrm>
+          <a:prstGeom prst="rect">
+            <a:avLst/>
+          </a:prstGeom>
+          <a:noFill/>
+          <a:ln>
+            <a:noFill/>
+          </a:ln>
+        </p:spPr>
+        <p:txBody>
+          <a:bodyPr anchorCtr="0" anchor="t" bIns="25400" lIns="25400" spcFirstLastPara="1" rIns="25400" wrap="square" tIns="25400">
+            <a:noAutofit/>
+          </a:bodyPr>
+          <a:lstStyle/>
+          <a:p>
+            <a:pPr indent="0" lvl="0" marL="0" marR="0" rtl="0" algn="l">
+              <a:spcBef>
+                <a:spcPts val="0"/>
+              </a:spcBef>
+              <a:spcAft>
+                <a:spcPts val="0"/>
+              </a:spcAft>
+              <a:buClr>
+                <a:srgbClr val="FFE5F0"/>
+              </a:buClr>
+              <a:buSzPts val="2325"/>
+              <a:buFont typeface="Manrope"/>
+              <a:buNone/>
+            </a:pPr>
+            <a:r>
+              <a:rPr b="1" i="0" lang="en-US" sz="2325" u="none" cap="none" strike="noStrike">
+                <a:solidFill>
+                  <a:srgbClr val="FFE5F0"/>
+                </a:solidFill>
+                <a:latin typeface="Manrope"/>
+                <a:ea typeface="Manrope"/>
+                <a:cs typeface="Manrope"/>
+                <a:sym typeface="Manrope"/>
+              </a:rPr>
+              <a:t>O1 + O2 + O3 + O4 = nuestro entregable</a:t>
+            </a:r>
+            <a:endParaRPr b="0" i="0" sz="2325" u="none" cap="none" strike="noStrike">
+              <a:solidFill>
+                <a:schemeClr val="dk1"/>
+              </a:solidFill>
+              <a:latin typeface="Calibri"/>
+              <a:ea typeface="Calibri"/>
+              <a:cs typeface="Calibri"/>
+              <a:sym typeface="Calibri"/>
+            </a:endParaRPr>
+          </a:p>
+        </p:txBody>
+      </p:sp>
+      <p:sp>
+        <p:nvSpPr>
+          <p:cNvPr id="132" name="Google Shape;132;p7"/>
+          <p:cNvSpPr/>
+          <p:nvPr/>
+        </p:nvSpPr>
+        <p:spPr>
+          <a:xfrm>
+            <a:off x="7724676" y="9304406"/>
+            <a:ext cx="9650105" cy="412750"/>
+          </a:xfrm>
+          <a:prstGeom prst="rect">
+            <a:avLst/>
+          </a:prstGeom>
+          <a:noFill/>
+          <a:ln>
+            <a:noFill/>
+          </a:ln>
+        </p:spPr>
+        <p:txBody>
+          <a:bodyPr anchorCtr="0" anchor="t" bIns="25400" lIns="25400" spcFirstLastPara="1" rIns="25400" wrap="square" tIns="25400">
+            <a:noAutofit/>
+          </a:bodyPr>
+          <a:lstStyle/>
+          <a:p>
+            <a:pPr indent="0" lvl="0" marL="0" marR="0" rtl="0" algn="l">
+              <a:spcBef>
+                <a:spcPts val="0"/>
+              </a:spcBef>
+              <a:spcAft>
+                <a:spcPts val="0"/>
+              </a:spcAft>
+              <a:buClr>
+                <a:srgbClr val="E8BFD0"/>
+              </a:buClr>
+              <a:buSzPts val="2175"/>
+              <a:buFont typeface="Manrope"/>
+              <a:buNone/>
+            </a:pPr>
+            <a:r>
+              <a:rPr b="0" i="0" lang="en-US" sz="2175" u="none" cap="none" strike="noStrike">
+                <a:solidFill>
+                  <a:srgbClr val="E8BFD0"/>
+                </a:solidFill>
+                <a:latin typeface="Manrope"/>
+                <a:ea typeface="Manrope"/>
+                <a:cs typeface="Manrope"/>
+                <a:sym typeface="Manrope"/>
+              </a:rPr>
+              <a:t>una experiencia VR validada en aula que entrega datos a los docentes</a:t>
+            </a:r>
+            <a:endParaRPr b="0" i="0" sz="2175" u="none" cap="none" strike="noStrike">
+              <a:solidFill>
+                <a:schemeClr val="dk1"/>
+              </a:solidFill>
+              <a:latin typeface="Calibri"/>
+              <a:ea typeface="Calibri"/>
+              <a:cs typeface="Calibri"/>
+              <a:sym typeface="Calibri"/>
+            </a:endParaRPr>
+          </a:p>
+        </p:txBody>
+      </p:sp>
+      <p:sp>
+        <p:nvSpPr>
+          <p:cNvPr id="133" name="Google Shape;133;p7"/>
+          <p:cNvSpPr/>
+          <p:nvPr/>
+        </p:nvSpPr>
+        <p:spPr>
+          <a:xfrm>
+            <a:off x="952500" y="9970493"/>
+            <a:ext cx="2992527" cy="349250"/>
+          </a:xfrm>
+          <a:prstGeom prst="rect">
+            <a:avLst/>
+          </a:prstGeom>
+          <a:noFill/>
+          <a:ln>
+            <a:noFill/>
+          </a:ln>
+        </p:spPr>
+        <p:txBody>
+          <a:bodyPr anchorCtr="0" anchor="t" bIns="25400" lIns="25400" spcFirstLastPara="1" rIns="25400" wrap="square" tIns="25400">
+            <a:noAutofit/>
+          </a:bodyPr>
+          <a:lstStyle/>
+          <a:p>
+            <a:pPr indent="0" lvl="0" marL="0" marR="0" rtl="0" algn="l">
+              <a:spcBef>
+                <a:spcPts val="0"/>
+              </a:spcBef>
+              <a:spcAft>
+                <a:spcPts val="0"/>
+              </a:spcAft>
+              <a:buClr>
+                <a:srgbClr val="9A8B92"/>
+              </a:buClr>
+              <a:buSzPts val="1800"/>
+              <a:buFont typeface="Manrope"/>
+              <a:buNone/>
+            </a:pPr>
+            <a:r>
+              <a:rPr b="0" i="0" lang="en-US" sz="1800" u="none" cap="none" strike="noStrike">
+                <a:solidFill>
+                  <a:srgbClr val="9A8B92"/>
+                </a:solidFill>
+                <a:latin typeface="Manrope"/>
+                <a:ea typeface="Manrope"/>
+                <a:cs typeface="Manrope"/>
+                <a:sym typeface="Manrope"/>
+              </a:rPr>
+              <a:t>EmotionLab · Capstone</a:t>
             </a:r>
             <a:endParaRPr b="0" i="0" sz="1800" u="none" cap="none" strike="noStrike">
               <a:solidFill>
@@ -10057,790 +10062,7 @@
       </p:sp>
       <p:sp>
         <p:nvSpPr>
-          <p:cNvPr id="132" name="Google Shape;132;p7"/>
-          <p:cNvSpPr/>
-          <p:nvPr/>
-        </p:nvSpPr>
-        <p:spPr>
-          <a:xfrm>
-            <a:off x="9353550" y="5787300"/>
-            <a:ext cx="3435688" cy="19050"/>
-          </a:xfrm>
-          <a:prstGeom prst="rect">
-            <a:avLst/>
-          </a:prstGeom>
-          <a:solidFill>
-            <a:srgbClr val="C594AA">
-              <a:alpha val="96078"/>
-            </a:srgbClr>
-          </a:solidFill>
-          <a:ln>
-            <a:noFill/>
-          </a:ln>
-        </p:spPr>
-        <p:txBody>
-          <a:bodyPr anchorCtr="0" anchor="ctr" bIns="91425" lIns="91425" spcFirstLastPara="1" rIns="91425" wrap="square" tIns="91425">
-            <a:noAutofit/>
-          </a:bodyPr>
-          <a:lstStyle/>
-          <a:p>
-            <a:pPr indent="0" lvl="0" marL="0" rtl="0" algn="l">
-              <a:spcBef>
-                <a:spcPts val="0"/>
-              </a:spcBef>
-              <a:spcAft>
-                <a:spcPts val="0"/>
-              </a:spcAft>
-              <a:buNone/>
-            </a:pPr>
-            <a:r>
-              <a:t/>
-            </a:r>
-            <a:endParaRPr/>
-          </a:p>
-        </p:txBody>
-      </p:sp>
-      <p:sp>
-        <p:nvSpPr>
-          <p:cNvPr id="133" name="Google Shape;133;p7"/>
-          <p:cNvSpPr/>
-          <p:nvPr/>
-        </p:nvSpPr>
-        <p:spPr>
-          <a:xfrm>
-            <a:off x="9353550" y="6034950"/>
-            <a:ext cx="3894868" cy="800100"/>
-          </a:xfrm>
-          <a:prstGeom prst="rect">
-            <a:avLst/>
-          </a:prstGeom>
-          <a:noFill/>
-          <a:ln>
-            <a:noFill/>
-          </a:ln>
-        </p:spPr>
-        <p:txBody>
-          <a:bodyPr anchorCtr="0" anchor="t" bIns="25400" lIns="25400" spcFirstLastPara="1" rIns="25400" wrap="square" tIns="25400">
-            <a:noAutofit/>
-          </a:bodyPr>
-          <a:lstStyle/>
-          <a:p>
-            <a:pPr indent="0" lvl="0" marL="0" marR="0" rtl="0" algn="l">
-              <a:lnSpc>
-                <a:spcPct val="92308"/>
-              </a:lnSpc>
-              <a:spcBef>
-                <a:spcPts val="0"/>
-              </a:spcBef>
-              <a:spcAft>
-                <a:spcPts val="0"/>
-              </a:spcAft>
-              <a:buClr>
-                <a:srgbClr val="0F3460"/>
-              </a:buClr>
-              <a:buSzPts val="2400"/>
-              <a:buFont typeface="Manrope"/>
-              <a:buNone/>
-            </a:pPr>
-            <a:r>
-              <a:rPr b="1" i="0" lang="en-US" sz="2400" u="none" cap="none" strike="noStrike">
-                <a:solidFill>
-                  <a:srgbClr val="0F3460"/>
-                </a:solidFill>
-                <a:latin typeface="Manrope"/>
-                <a:ea typeface="Manrope"/>
-                <a:cs typeface="Manrope"/>
-                <a:sym typeface="Manrope"/>
-              </a:rPr>
-              <a:t>Ejecutar las pruebas de campo</a:t>
-            </a:r>
-            <a:endParaRPr b="0" i="0" sz="2400" u="none" cap="none" strike="noStrike">
-              <a:solidFill>
-                <a:schemeClr val="dk1"/>
-              </a:solidFill>
-              <a:latin typeface="Calibri"/>
-              <a:ea typeface="Calibri"/>
-              <a:cs typeface="Calibri"/>
-              <a:sym typeface="Calibri"/>
-            </a:endParaRPr>
-          </a:p>
-        </p:txBody>
-      </p:sp>
-      <p:sp>
-        <p:nvSpPr>
           <p:cNvPr id="134" name="Google Shape;134;p7"/>
-          <p:cNvSpPr/>
-          <p:nvPr/>
-        </p:nvSpPr>
-        <p:spPr>
-          <a:xfrm>
-            <a:off x="9353550" y="6949350"/>
-            <a:ext cx="3894868" cy="781050"/>
-          </a:xfrm>
-          <a:prstGeom prst="rect">
-            <a:avLst/>
-          </a:prstGeom>
-          <a:noFill/>
-          <a:ln>
-            <a:noFill/>
-          </a:ln>
-        </p:spPr>
-        <p:txBody>
-          <a:bodyPr anchorCtr="0" anchor="t" bIns="25400" lIns="25400" spcFirstLastPara="1" rIns="25400" wrap="square" tIns="25400">
-            <a:noAutofit/>
-          </a:bodyPr>
-          <a:lstStyle/>
-          <a:p>
-            <a:pPr indent="0" lvl="0" marL="0" marR="0" rtl="0" algn="l">
-              <a:lnSpc>
-                <a:spcPct val="108333"/>
-              </a:lnSpc>
-              <a:spcBef>
-                <a:spcPts val="0"/>
-              </a:spcBef>
-              <a:spcAft>
-                <a:spcPts val="0"/>
-              </a:spcAft>
-              <a:buClr>
-                <a:srgbClr val="4A4A4A"/>
-              </a:buClr>
-              <a:buSzPts val="1950"/>
-              <a:buFont typeface="Manrope"/>
-              <a:buNone/>
-            </a:pPr>
-            <a:r>
-              <a:rPr b="0" i="0" lang="en-US" sz="1950" u="none" cap="none" strike="noStrike">
-                <a:solidFill>
-                  <a:srgbClr val="4A4A4A"/>
-                </a:solidFill>
-                <a:latin typeface="Manrope"/>
-                <a:ea typeface="Manrope"/>
-                <a:cs typeface="Manrope"/>
-                <a:sym typeface="Manrope"/>
-              </a:rPr>
-              <a:t>Viña del Mar: 20 estudiantes, dos veces por semana, un mes.</a:t>
-            </a:r>
-            <a:endParaRPr b="0" i="0" sz="1950" u="none" cap="none" strike="noStrike">
-              <a:solidFill>
-                <a:schemeClr val="dk1"/>
-              </a:solidFill>
-              <a:latin typeface="Calibri"/>
-              <a:ea typeface="Calibri"/>
-              <a:cs typeface="Calibri"/>
-              <a:sym typeface="Calibri"/>
-            </a:endParaRPr>
-          </a:p>
-        </p:txBody>
-      </p:sp>
-      <p:sp>
-        <p:nvSpPr>
-          <p:cNvPr id="135" name="Google Shape;135;p7"/>
-          <p:cNvSpPr/>
-          <p:nvPr/>
-        </p:nvSpPr>
-        <p:spPr>
-          <a:xfrm>
-            <a:off x="9353550" y="7844700"/>
-            <a:ext cx="3894868" cy="700881"/>
-          </a:xfrm>
-          <a:prstGeom prst="rect">
-            <a:avLst/>
-          </a:prstGeom>
-          <a:noFill/>
-          <a:ln>
-            <a:noFill/>
-          </a:ln>
-        </p:spPr>
-        <p:txBody>
-          <a:bodyPr anchorCtr="0" anchor="t" bIns="25400" lIns="25400" spcFirstLastPara="1" rIns="25400" wrap="square" tIns="25400">
-            <a:noAutofit/>
-          </a:bodyPr>
-          <a:lstStyle/>
-          <a:p>
-            <a:pPr indent="0" lvl="0" marL="0" marR="0" rtl="0" algn="l">
-              <a:lnSpc>
-                <a:spcPct val="106531"/>
-              </a:lnSpc>
-              <a:spcBef>
-                <a:spcPts val="0"/>
-              </a:spcBef>
-              <a:spcAft>
-                <a:spcPts val="0"/>
-              </a:spcAft>
-              <a:buClr>
-                <a:srgbClr val="6B5B64"/>
-              </a:buClr>
-              <a:buSzPts val="1800"/>
-              <a:buFont typeface="Manrope"/>
-              <a:buNone/>
-            </a:pPr>
-            <a:r>
-              <a:rPr b="0" i="1" lang="en-US" sz="1800" u="none" cap="none" strike="noStrike">
-                <a:solidFill>
-                  <a:srgbClr val="6B5B64"/>
-                </a:solidFill>
-                <a:latin typeface="Manrope"/>
-                <a:ea typeface="Manrope"/>
-                <a:cs typeface="Manrope"/>
-                <a:sym typeface="Manrope"/>
-              </a:rPr>
-              <a:t>Cómo: sesiones coordinadas con el colegio.</a:t>
-            </a:r>
-            <a:endParaRPr b="0" i="0" sz="1800" u="none" cap="none" strike="noStrike">
-              <a:solidFill>
-                <a:schemeClr val="dk1"/>
-              </a:solidFill>
-              <a:latin typeface="Calibri"/>
-              <a:ea typeface="Calibri"/>
-              <a:cs typeface="Calibri"/>
-              <a:sym typeface="Calibri"/>
-            </a:endParaRPr>
-          </a:p>
-        </p:txBody>
-      </p:sp>
-      <p:sp>
-        <p:nvSpPr>
-          <p:cNvPr id="136" name="Google Shape;136;p7"/>
-          <p:cNvSpPr/>
-          <p:nvPr/>
-        </p:nvSpPr>
-        <p:spPr>
-          <a:xfrm>
-            <a:off x="13554075" y="5323749"/>
-            <a:ext cx="4159568" cy="349250"/>
-          </a:xfrm>
-          <a:prstGeom prst="rect">
-            <a:avLst/>
-          </a:prstGeom>
-          <a:noFill/>
-          <a:ln>
-            <a:noFill/>
-          </a:ln>
-        </p:spPr>
-        <p:txBody>
-          <a:bodyPr anchorCtr="0" anchor="t" bIns="25400" lIns="25400" spcFirstLastPara="1" rIns="25400" wrap="square" tIns="25400">
-            <a:noAutofit/>
-          </a:bodyPr>
-          <a:lstStyle/>
-          <a:p>
-            <a:pPr indent="0" lvl="0" marL="0" marR="0" rtl="0" algn="l">
-              <a:spcBef>
-                <a:spcPts val="0"/>
-              </a:spcBef>
-              <a:spcAft>
-                <a:spcPts val="0"/>
-              </a:spcAft>
-              <a:buClr>
-                <a:srgbClr val="B07F96"/>
-              </a:buClr>
-              <a:buSzPts val="1800"/>
-              <a:buFont typeface="Manrope"/>
-              <a:buNone/>
-            </a:pPr>
-            <a:r>
-              <a:rPr b="1" i="0" lang="en-US" sz="1800" u="none" cap="none" strike="noStrike">
-                <a:solidFill>
-                  <a:srgbClr val="B07F96"/>
-                </a:solidFill>
-                <a:latin typeface="Manrope"/>
-                <a:ea typeface="Manrope"/>
-                <a:cs typeface="Manrope"/>
-                <a:sym typeface="Manrope"/>
-              </a:rPr>
-              <a:t>O4</a:t>
-            </a:r>
-            <a:endParaRPr b="0" i="0" sz="1800" u="none" cap="none" strike="noStrike">
-              <a:solidFill>
-                <a:schemeClr val="dk1"/>
-              </a:solidFill>
-              <a:latin typeface="Calibri"/>
-              <a:ea typeface="Calibri"/>
-              <a:cs typeface="Calibri"/>
-              <a:sym typeface="Calibri"/>
-            </a:endParaRPr>
-          </a:p>
-        </p:txBody>
-      </p:sp>
-      <p:sp>
-        <p:nvSpPr>
-          <p:cNvPr id="137" name="Google Shape;137;p7"/>
-          <p:cNvSpPr/>
-          <p:nvPr/>
-        </p:nvSpPr>
-        <p:spPr>
-          <a:xfrm>
-            <a:off x="13554075" y="5787300"/>
-            <a:ext cx="3435688" cy="19050"/>
-          </a:xfrm>
-          <a:prstGeom prst="rect">
-            <a:avLst/>
-          </a:prstGeom>
-          <a:solidFill>
-            <a:srgbClr val="C594AA">
-              <a:alpha val="96078"/>
-            </a:srgbClr>
-          </a:solidFill>
-          <a:ln>
-            <a:noFill/>
-          </a:ln>
-        </p:spPr>
-        <p:txBody>
-          <a:bodyPr anchorCtr="0" anchor="ctr" bIns="91425" lIns="91425" spcFirstLastPara="1" rIns="91425" wrap="square" tIns="91425">
-            <a:noAutofit/>
-          </a:bodyPr>
-          <a:lstStyle/>
-          <a:p>
-            <a:pPr indent="0" lvl="0" marL="0" rtl="0" algn="l">
-              <a:spcBef>
-                <a:spcPts val="0"/>
-              </a:spcBef>
-              <a:spcAft>
-                <a:spcPts val="0"/>
-              </a:spcAft>
-              <a:buNone/>
-            </a:pPr>
-            <a:r>
-              <a:t/>
-            </a:r>
-            <a:endParaRPr/>
-          </a:p>
-        </p:txBody>
-      </p:sp>
-      <p:sp>
-        <p:nvSpPr>
-          <p:cNvPr id="138" name="Google Shape;138;p7"/>
-          <p:cNvSpPr/>
-          <p:nvPr/>
-        </p:nvSpPr>
-        <p:spPr>
-          <a:xfrm>
-            <a:off x="13554075" y="6034950"/>
-            <a:ext cx="3894868" cy="800100"/>
-          </a:xfrm>
-          <a:prstGeom prst="rect">
-            <a:avLst/>
-          </a:prstGeom>
-          <a:noFill/>
-          <a:ln>
-            <a:noFill/>
-          </a:ln>
-        </p:spPr>
-        <p:txBody>
-          <a:bodyPr anchorCtr="0" anchor="t" bIns="25400" lIns="25400" spcFirstLastPara="1" rIns="25400" wrap="square" tIns="25400">
-            <a:noAutofit/>
-          </a:bodyPr>
-          <a:lstStyle/>
-          <a:p>
-            <a:pPr indent="0" lvl="0" marL="0" marR="0" rtl="0" algn="l">
-              <a:lnSpc>
-                <a:spcPct val="92308"/>
-              </a:lnSpc>
-              <a:spcBef>
-                <a:spcPts val="0"/>
-              </a:spcBef>
-              <a:spcAft>
-                <a:spcPts val="0"/>
-              </a:spcAft>
-              <a:buClr>
-                <a:srgbClr val="0F3460"/>
-              </a:buClr>
-              <a:buSzPts val="2400"/>
-              <a:buFont typeface="Manrope"/>
-              <a:buNone/>
-            </a:pPr>
-            <a:r>
-              <a:rPr b="1" i="0" lang="en-US" sz="2400" u="none" cap="none" strike="noStrike">
-                <a:solidFill>
-                  <a:srgbClr val="0F3460"/>
-                </a:solidFill>
-                <a:latin typeface="Manrope"/>
-                <a:ea typeface="Manrope"/>
-                <a:cs typeface="Manrope"/>
-                <a:sym typeface="Manrope"/>
-              </a:rPr>
-              <a:t>Proteger la privacidad de los datos</a:t>
-            </a:r>
-            <a:endParaRPr b="0" i="0" sz="2400" u="none" cap="none" strike="noStrike">
-              <a:solidFill>
-                <a:schemeClr val="dk1"/>
-              </a:solidFill>
-              <a:latin typeface="Calibri"/>
-              <a:ea typeface="Calibri"/>
-              <a:cs typeface="Calibri"/>
-              <a:sym typeface="Calibri"/>
-            </a:endParaRPr>
-          </a:p>
-        </p:txBody>
-      </p:sp>
-      <p:sp>
-        <p:nvSpPr>
-          <p:cNvPr id="139" name="Google Shape;139;p7"/>
-          <p:cNvSpPr/>
-          <p:nvPr/>
-        </p:nvSpPr>
-        <p:spPr>
-          <a:xfrm>
-            <a:off x="13554075" y="6949350"/>
-            <a:ext cx="3894868" cy="781050"/>
-          </a:xfrm>
-          <a:prstGeom prst="rect">
-            <a:avLst/>
-          </a:prstGeom>
-          <a:noFill/>
-          <a:ln>
-            <a:noFill/>
-          </a:ln>
-        </p:spPr>
-        <p:txBody>
-          <a:bodyPr anchorCtr="0" anchor="t" bIns="25400" lIns="25400" spcFirstLastPara="1" rIns="25400" wrap="square" tIns="25400">
-            <a:noAutofit/>
-          </a:bodyPr>
-          <a:lstStyle/>
-          <a:p>
-            <a:pPr indent="0" lvl="0" marL="0" marR="0" rtl="0" algn="l">
-              <a:lnSpc>
-                <a:spcPct val="108333"/>
-              </a:lnSpc>
-              <a:spcBef>
-                <a:spcPts val="0"/>
-              </a:spcBef>
-              <a:spcAft>
-                <a:spcPts val="0"/>
-              </a:spcAft>
-              <a:buClr>
-                <a:srgbClr val="4A4A4A"/>
-              </a:buClr>
-              <a:buSzPts val="1950"/>
-              <a:buFont typeface="Manrope"/>
-              <a:buNone/>
-            </a:pPr>
-            <a:r>
-              <a:rPr b="0" i="0" lang="en-US" sz="1950" u="none" cap="none" strike="noStrike">
-                <a:solidFill>
-                  <a:srgbClr val="4A4A4A"/>
-                </a:solidFill>
-                <a:latin typeface="Manrope"/>
-                <a:ea typeface="Manrope"/>
-                <a:cs typeface="Manrope"/>
-                <a:sym typeface="Manrope"/>
-              </a:rPr>
-              <a:t>Menores de edad: anonimización estricta.</a:t>
-            </a:r>
-            <a:endParaRPr b="0" i="0" sz="1950" u="none" cap="none" strike="noStrike">
-              <a:solidFill>
-                <a:schemeClr val="dk1"/>
-              </a:solidFill>
-              <a:latin typeface="Calibri"/>
-              <a:ea typeface="Calibri"/>
-              <a:cs typeface="Calibri"/>
-              <a:sym typeface="Calibri"/>
-            </a:endParaRPr>
-          </a:p>
-        </p:txBody>
-      </p:sp>
-      <p:sp>
-        <p:nvSpPr>
-          <p:cNvPr id="140" name="Google Shape;140;p7"/>
-          <p:cNvSpPr/>
-          <p:nvPr/>
-        </p:nvSpPr>
-        <p:spPr>
-          <a:xfrm>
-            <a:off x="13554075" y="7844700"/>
-            <a:ext cx="3894868" cy="700881"/>
-          </a:xfrm>
-          <a:prstGeom prst="rect">
-            <a:avLst/>
-          </a:prstGeom>
-          <a:noFill/>
-          <a:ln>
-            <a:noFill/>
-          </a:ln>
-        </p:spPr>
-        <p:txBody>
-          <a:bodyPr anchorCtr="0" anchor="t" bIns="25400" lIns="25400" spcFirstLastPara="1" rIns="25400" wrap="square" tIns="25400">
-            <a:noAutofit/>
-          </a:bodyPr>
-          <a:lstStyle/>
-          <a:p>
-            <a:pPr indent="0" lvl="0" marL="0" marR="0" rtl="0" algn="l">
-              <a:lnSpc>
-                <a:spcPct val="106531"/>
-              </a:lnSpc>
-              <a:spcBef>
-                <a:spcPts val="0"/>
-              </a:spcBef>
-              <a:spcAft>
-                <a:spcPts val="0"/>
-              </a:spcAft>
-              <a:buClr>
-                <a:srgbClr val="6B5B64"/>
-              </a:buClr>
-              <a:buSzPts val="1800"/>
-              <a:buFont typeface="Manrope"/>
-              <a:buNone/>
-            </a:pPr>
-            <a:r>
-              <a:rPr b="0" i="1" lang="en-US" sz="1800" u="none" cap="none" strike="noStrike">
-                <a:solidFill>
-                  <a:srgbClr val="6B5B64"/>
-                </a:solidFill>
-                <a:latin typeface="Manrope"/>
-                <a:ea typeface="Manrope"/>
-                <a:cs typeface="Manrope"/>
-                <a:sym typeface="Manrope"/>
-              </a:rPr>
-              <a:t>Cómo: cifrado y consentimiento de cada apoderado.</a:t>
-            </a:r>
-            <a:endParaRPr b="0" i="0" sz="1800" u="none" cap="none" strike="noStrike">
-              <a:solidFill>
-                <a:schemeClr val="dk1"/>
-              </a:solidFill>
-              <a:latin typeface="Calibri"/>
-              <a:ea typeface="Calibri"/>
-              <a:cs typeface="Calibri"/>
-              <a:sym typeface="Calibri"/>
-            </a:endParaRPr>
-          </a:p>
-        </p:txBody>
-      </p:sp>
-      <p:sp>
-        <p:nvSpPr>
-          <p:cNvPr id="141" name="Google Shape;141;p7"/>
-          <p:cNvSpPr/>
-          <p:nvPr/>
-        </p:nvSpPr>
-        <p:spPr>
-          <a:xfrm>
-            <a:off x="952500" y="9002781"/>
-            <a:ext cx="16383000" cy="977900"/>
-          </a:xfrm>
-          <a:prstGeom prst="rect">
-            <a:avLst/>
-          </a:prstGeom>
-          <a:solidFill>
-            <a:srgbClr val="0F3460">
-              <a:alpha val="96078"/>
-            </a:srgbClr>
-          </a:solidFill>
-          <a:ln>
-            <a:noFill/>
-          </a:ln>
-        </p:spPr>
-        <p:txBody>
-          <a:bodyPr anchorCtr="0" anchor="ctr" bIns="91425" lIns="91425" spcFirstLastPara="1" rIns="91425" wrap="square" tIns="91425">
-            <a:noAutofit/>
-          </a:bodyPr>
-          <a:lstStyle/>
-          <a:p>
-            <a:pPr indent="0" lvl="0" marL="0" rtl="0" algn="l">
-              <a:spcBef>
-                <a:spcPts val="0"/>
-              </a:spcBef>
-              <a:spcAft>
-                <a:spcPts val="0"/>
-              </a:spcAft>
-              <a:buNone/>
-            </a:pPr>
-            <a:r>
-              <a:t/>
-            </a:r>
-            <a:endParaRPr/>
-          </a:p>
-        </p:txBody>
-      </p:sp>
-      <p:sp>
-        <p:nvSpPr>
-          <p:cNvPr id="142" name="Google Shape;142;p7"/>
-          <p:cNvSpPr/>
-          <p:nvPr/>
-        </p:nvSpPr>
-        <p:spPr>
-          <a:xfrm>
-            <a:off x="1790402" y="9288531"/>
-            <a:ext cx="6297196" cy="444500"/>
-          </a:xfrm>
-          <a:prstGeom prst="rect">
-            <a:avLst/>
-          </a:prstGeom>
-          <a:noFill/>
-          <a:ln>
-            <a:noFill/>
-          </a:ln>
-        </p:spPr>
-        <p:txBody>
-          <a:bodyPr anchorCtr="0" anchor="t" bIns="25400" lIns="25400" spcFirstLastPara="1" rIns="25400" wrap="square" tIns="25400">
-            <a:noAutofit/>
-          </a:bodyPr>
-          <a:lstStyle/>
-          <a:p>
-            <a:pPr indent="0" lvl="0" marL="0" marR="0" rtl="0" algn="l">
-              <a:spcBef>
-                <a:spcPts val="0"/>
-              </a:spcBef>
-              <a:spcAft>
-                <a:spcPts val="0"/>
-              </a:spcAft>
-              <a:buClr>
-                <a:srgbClr val="FFE5F0"/>
-              </a:buClr>
-              <a:buSzPts val="2325"/>
-              <a:buFont typeface="Manrope"/>
-              <a:buNone/>
-            </a:pPr>
-            <a:r>
-              <a:rPr b="1" i="0" lang="en-US" sz="2325" u="none" cap="none" strike="noStrike">
-                <a:solidFill>
-                  <a:srgbClr val="FFE5F0"/>
-                </a:solidFill>
-                <a:latin typeface="Manrope"/>
-                <a:ea typeface="Manrope"/>
-                <a:cs typeface="Manrope"/>
-                <a:sym typeface="Manrope"/>
-              </a:rPr>
-              <a:t>O1 + O2 + O3 + O4 = nuestro entregable</a:t>
-            </a:r>
-            <a:endParaRPr b="0" i="0" sz="2325" u="none" cap="none" strike="noStrike">
-              <a:solidFill>
-                <a:schemeClr val="dk1"/>
-              </a:solidFill>
-              <a:latin typeface="Calibri"/>
-              <a:ea typeface="Calibri"/>
-              <a:cs typeface="Calibri"/>
-              <a:sym typeface="Calibri"/>
-            </a:endParaRPr>
-          </a:p>
-        </p:txBody>
-      </p:sp>
-      <p:sp>
-        <p:nvSpPr>
-          <p:cNvPr id="143" name="Google Shape;143;p7"/>
-          <p:cNvSpPr/>
-          <p:nvPr/>
-        </p:nvSpPr>
-        <p:spPr>
-          <a:xfrm>
-            <a:off x="7724676" y="9304406"/>
-            <a:ext cx="9650105" cy="412750"/>
-          </a:xfrm>
-          <a:prstGeom prst="rect">
-            <a:avLst/>
-          </a:prstGeom>
-          <a:noFill/>
-          <a:ln>
-            <a:noFill/>
-          </a:ln>
-        </p:spPr>
-        <p:txBody>
-          <a:bodyPr anchorCtr="0" anchor="t" bIns="25400" lIns="25400" spcFirstLastPara="1" rIns="25400" wrap="square" tIns="25400">
-            <a:noAutofit/>
-          </a:bodyPr>
-          <a:lstStyle/>
-          <a:p>
-            <a:pPr indent="0" lvl="0" marL="0" marR="0" rtl="0" algn="l">
-              <a:spcBef>
-                <a:spcPts val="0"/>
-              </a:spcBef>
-              <a:spcAft>
-                <a:spcPts val="0"/>
-              </a:spcAft>
-              <a:buClr>
-                <a:srgbClr val="E8BFD0"/>
-              </a:buClr>
-              <a:buSzPts val="2175"/>
-              <a:buFont typeface="Manrope"/>
-              <a:buNone/>
-            </a:pPr>
-            <a:r>
-              <a:rPr b="0" i="0" lang="en-US" sz="2175" u="none" cap="none" strike="noStrike">
-                <a:solidFill>
-                  <a:srgbClr val="E8BFD0"/>
-                </a:solidFill>
-                <a:latin typeface="Manrope"/>
-                <a:ea typeface="Manrope"/>
-                <a:cs typeface="Manrope"/>
-                <a:sym typeface="Manrope"/>
-              </a:rPr>
-              <a:t>una experiencia VR validada en aula que entrega datos a los docentes</a:t>
-            </a:r>
-            <a:endParaRPr b="0" i="0" sz="2175" u="none" cap="none" strike="noStrike">
-              <a:solidFill>
-                <a:schemeClr val="dk1"/>
-              </a:solidFill>
-              <a:latin typeface="Calibri"/>
-              <a:ea typeface="Calibri"/>
-              <a:cs typeface="Calibri"/>
-              <a:sym typeface="Calibri"/>
-            </a:endParaRPr>
-          </a:p>
-        </p:txBody>
-      </p:sp>
-      <p:sp>
-        <p:nvSpPr>
-          <p:cNvPr id="144" name="Google Shape;144;p7"/>
-          <p:cNvSpPr/>
-          <p:nvPr/>
-        </p:nvSpPr>
-        <p:spPr>
-          <a:xfrm>
-            <a:off x="952500" y="9970493"/>
-            <a:ext cx="2992527" cy="349250"/>
-          </a:xfrm>
-          <a:prstGeom prst="rect">
-            <a:avLst/>
-          </a:prstGeom>
-          <a:noFill/>
-          <a:ln>
-            <a:noFill/>
-          </a:ln>
-        </p:spPr>
-        <p:txBody>
-          <a:bodyPr anchorCtr="0" anchor="t" bIns="25400" lIns="25400" spcFirstLastPara="1" rIns="25400" wrap="square" tIns="25400">
-            <a:noAutofit/>
-          </a:bodyPr>
-          <a:lstStyle/>
-          <a:p>
-            <a:pPr indent="0" lvl="0" marL="0" marR="0" rtl="0" algn="l">
-              <a:spcBef>
-                <a:spcPts val="0"/>
-              </a:spcBef>
-              <a:spcAft>
-                <a:spcPts val="0"/>
-              </a:spcAft>
-              <a:buClr>
-                <a:srgbClr val="9A8B92"/>
-              </a:buClr>
-              <a:buSzPts val="1800"/>
-              <a:buFont typeface="Manrope"/>
-              <a:buNone/>
-            </a:pPr>
-            <a:r>
-              <a:rPr b="0" i="0" lang="en-US" sz="1800" u="none" cap="none" strike="noStrike">
-                <a:solidFill>
-                  <a:srgbClr val="9A8B92"/>
-                </a:solidFill>
-                <a:latin typeface="Manrope"/>
-                <a:ea typeface="Manrope"/>
-                <a:cs typeface="Manrope"/>
-                <a:sym typeface="Manrope"/>
-              </a:rPr>
-              <a:t>EmotionLab · Capstone</a:t>
-            </a:r>
-            <a:endParaRPr b="0" i="0" sz="1800" u="none" cap="none" strike="noStrike">
-              <a:solidFill>
-                <a:schemeClr val="dk1"/>
-              </a:solidFill>
-              <a:latin typeface="Calibri"/>
-              <a:ea typeface="Calibri"/>
-              <a:cs typeface="Calibri"/>
-              <a:sym typeface="Calibri"/>
-            </a:endParaRPr>
-          </a:p>
-        </p:txBody>
-      </p:sp>
-      <p:sp>
-        <p:nvSpPr>
-          <p:cNvPr id="145" name="Google Shape;145;p7"/>
           <p:cNvSpPr/>
           <p:nvPr/>
         </p:nvSpPr>
@@ -10921,7 +10143,7 @@
     </p:bg>
     <p:spTree>
       <p:nvGrpSpPr>
-        <p:cNvPr id="150" name="Shape 150"/>
+        <p:cNvPr id="139" name="Shape 139"/>
         <p:cNvGrpSpPr/>
         <p:nvPr/>
       </p:nvGrpSpPr>
@@ -10935,7 +10157,7 @@
       </p:grpSpPr>
       <p:sp>
         <p:nvSpPr>
-          <p:cNvPr id="151" name="Google Shape;151;p8"/>
+          <p:cNvPr id="140" name="Google Shape;140;p8"/>
           <p:cNvSpPr/>
           <p:nvPr/>
         </p:nvSpPr>
@@ -10980,7 +10202,7 @@
       </p:sp>
       <p:sp>
         <p:nvSpPr>
-          <p:cNvPr id="152" name="Google Shape;152;p8"/>
+          <p:cNvPr id="141" name="Google Shape;141;p8"/>
           <p:cNvSpPr/>
           <p:nvPr/>
         </p:nvSpPr>
@@ -11043,7 +10265,7 @@
       </p:sp>
       <p:sp>
         <p:nvSpPr>
-          <p:cNvPr id="153" name="Google Shape;153;p8"/>
+          <p:cNvPr id="142" name="Google Shape;142;p8"/>
           <p:cNvSpPr/>
           <p:nvPr/>
         </p:nvSpPr>
@@ -11109,7 +10331,7 @@
       </p:sp>
       <p:sp>
         <p:nvSpPr>
-          <p:cNvPr id="154" name="Google Shape;154;p8"/>
+          <p:cNvPr id="143" name="Google Shape;143;p8"/>
           <p:cNvSpPr/>
           <p:nvPr/>
         </p:nvSpPr>
@@ -11172,7 +10394,7 @@
       </p:sp>
       <p:sp>
         <p:nvSpPr>
-          <p:cNvPr id="155" name="Google Shape;155;p8"/>
+          <p:cNvPr id="144" name="Google Shape;144;p8"/>
           <p:cNvSpPr/>
           <p:nvPr/>
         </p:nvSpPr>
@@ -11235,7 +10457,7 @@
       </p:sp>
       <p:sp>
         <p:nvSpPr>
-          <p:cNvPr id="156" name="Google Shape;156;p8"/>
+          <p:cNvPr id="145" name="Google Shape;145;p8"/>
           <p:cNvSpPr/>
           <p:nvPr/>
         </p:nvSpPr>
@@ -11298,7 +10520,7 @@
       </p:sp>
       <p:sp>
         <p:nvSpPr>
-          <p:cNvPr id="157" name="Google Shape;157;p8"/>
+          <p:cNvPr id="146" name="Google Shape;146;p8"/>
           <p:cNvSpPr/>
           <p:nvPr/>
         </p:nvSpPr>
@@ -11364,7 +10586,7 @@
       </p:sp>
       <p:sp>
         <p:nvSpPr>
-          <p:cNvPr id="158" name="Google Shape;158;p8"/>
+          <p:cNvPr id="147" name="Google Shape;147;p8"/>
           <p:cNvSpPr/>
           <p:nvPr/>
         </p:nvSpPr>
@@ -11427,7 +10649,7 @@
       </p:sp>
       <p:sp>
         <p:nvSpPr>
-          <p:cNvPr id="159" name="Google Shape;159;p8"/>
+          <p:cNvPr id="148" name="Google Shape;148;p8"/>
           <p:cNvSpPr/>
           <p:nvPr/>
         </p:nvSpPr>
@@ -11490,7 +10712,7 @@
       </p:sp>
       <p:sp>
         <p:nvSpPr>
-          <p:cNvPr id="160" name="Google Shape;160;p8"/>
+          <p:cNvPr id="149" name="Google Shape;149;p8"/>
           <p:cNvSpPr/>
           <p:nvPr/>
         </p:nvSpPr>
@@ -11556,7 +10778,7 @@
       </p:sp>
       <p:sp>
         <p:nvSpPr>
-          <p:cNvPr id="161" name="Google Shape;161;p8"/>
+          <p:cNvPr id="150" name="Google Shape;150;p8"/>
           <p:cNvSpPr/>
           <p:nvPr/>
         </p:nvSpPr>
@@ -11619,7 +10841,7 @@
       </p:sp>
       <p:sp>
         <p:nvSpPr>
-          <p:cNvPr id="162" name="Google Shape;162;p8"/>
+          <p:cNvPr id="151" name="Google Shape;151;p8"/>
           <p:cNvSpPr/>
           <p:nvPr/>
         </p:nvSpPr>
@@ -11682,7 +10904,7 @@
       </p:sp>
       <p:sp>
         <p:nvSpPr>
-          <p:cNvPr id="163" name="Google Shape;163;p8"/>
+          <p:cNvPr id="152" name="Google Shape;152;p8"/>
           <p:cNvSpPr/>
           <p:nvPr/>
         </p:nvSpPr>
@@ -11748,7 +10970,7 @@
       </p:sp>
       <p:sp>
         <p:nvSpPr>
-          <p:cNvPr id="164" name="Google Shape;164;p8"/>
+          <p:cNvPr id="153" name="Google Shape;153;p8"/>
           <p:cNvSpPr/>
           <p:nvPr/>
         </p:nvSpPr>
@@ -11811,7 +11033,7 @@
       </p:sp>
       <p:sp>
         <p:nvSpPr>
-          <p:cNvPr id="165" name="Google Shape;165;p8"/>
+          <p:cNvPr id="154" name="Google Shape;154;p8"/>
           <p:cNvSpPr/>
           <p:nvPr/>
         </p:nvSpPr>
@@ -11874,7 +11096,7 @@
       </p:sp>
       <p:sp>
         <p:nvSpPr>
-          <p:cNvPr id="166" name="Google Shape;166;p8"/>
+          <p:cNvPr id="155" name="Google Shape;155;p8"/>
           <p:cNvSpPr/>
           <p:nvPr/>
         </p:nvSpPr>
@@ -11940,7 +11162,7 @@
       </p:sp>
       <p:sp>
         <p:nvSpPr>
-          <p:cNvPr id="167" name="Google Shape;167;p8"/>
+          <p:cNvPr id="156" name="Google Shape;156;p8"/>
           <p:cNvSpPr/>
           <p:nvPr/>
         </p:nvSpPr>
@@ -11983,7 +11205,7 @@
       </p:sp>
       <p:sp>
         <p:nvSpPr>
-          <p:cNvPr id="168" name="Google Shape;168;p8"/>
+          <p:cNvPr id="157" name="Google Shape;157;p8"/>
           <p:cNvSpPr/>
           <p:nvPr/>
         </p:nvSpPr>
@@ -12046,7 +11268,7 @@
       </p:sp>
       <p:sp>
         <p:nvSpPr>
-          <p:cNvPr id="169" name="Google Shape;169;p8"/>
+          <p:cNvPr id="158" name="Google Shape;158;p8"/>
           <p:cNvSpPr/>
           <p:nvPr/>
         </p:nvSpPr>
@@ -12091,7 +11313,7 @@
       </p:sp>
       <p:sp>
         <p:nvSpPr>
-          <p:cNvPr id="170" name="Google Shape;170;p8"/>
+          <p:cNvPr id="159" name="Google Shape;159;p8"/>
           <p:cNvSpPr/>
           <p:nvPr/>
         </p:nvSpPr>
@@ -12136,7 +11358,7 @@
       </p:sp>
       <p:sp>
         <p:nvSpPr>
-          <p:cNvPr id="171" name="Google Shape;171;p8"/>
+          <p:cNvPr id="160" name="Google Shape;160;p8"/>
           <p:cNvSpPr/>
           <p:nvPr/>
         </p:nvSpPr>
@@ -12199,7 +11421,7 @@
       </p:sp>
       <p:sp>
         <p:nvSpPr>
-          <p:cNvPr id="172" name="Google Shape;172;p8"/>
+          <p:cNvPr id="161" name="Google Shape;161;p8"/>
           <p:cNvSpPr/>
           <p:nvPr/>
         </p:nvSpPr>
@@ -12265,7 +11487,7 @@
       </p:sp>
       <p:sp>
         <p:nvSpPr>
-          <p:cNvPr id="173" name="Google Shape;173;p8"/>
+          <p:cNvPr id="162" name="Google Shape;162;p8"/>
           <p:cNvSpPr/>
           <p:nvPr/>
         </p:nvSpPr>
@@ -12310,7 +11532,7 @@
       </p:sp>
       <p:sp>
         <p:nvSpPr>
-          <p:cNvPr id="174" name="Google Shape;174;p8"/>
+          <p:cNvPr id="163" name="Google Shape;163;p8"/>
           <p:cNvSpPr/>
           <p:nvPr/>
         </p:nvSpPr>
@@ -12355,7 +11577,7 @@
       </p:sp>
       <p:sp>
         <p:nvSpPr>
-          <p:cNvPr id="175" name="Google Shape;175;p8"/>
+          <p:cNvPr id="164" name="Google Shape;164;p8"/>
           <p:cNvSpPr/>
           <p:nvPr/>
         </p:nvSpPr>
@@ -12418,7 +11640,7 @@
       </p:sp>
       <p:sp>
         <p:nvSpPr>
-          <p:cNvPr id="176" name="Google Shape;176;p8"/>
+          <p:cNvPr id="165" name="Google Shape;165;p8"/>
           <p:cNvSpPr/>
           <p:nvPr/>
         </p:nvSpPr>
@@ -12484,7 +11706,7 @@
       </p:sp>
       <p:sp>
         <p:nvSpPr>
-          <p:cNvPr id="177" name="Google Shape;177;p8"/>
+          <p:cNvPr id="166" name="Google Shape;166;p8"/>
           <p:cNvSpPr/>
           <p:nvPr/>
         </p:nvSpPr>
@@ -12529,7 +11751,7 @@
       </p:sp>
       <p:sp>
         <p:nvSpPr>
-          <p:cNvPr id="178" name="Google Shape;178;p8"/>
+          <p:cNvPr id="167" name="Google Shape;167;p8"/>
           <p:cNvSpPr/>
           <p:nvPr/>
         </p:nvSpPr>
@@ -12574,7 +11796,7 @@
       </p:sp>
       <p:sp>
         <p:nvSpPr>
-          <p:cNvPr id="179" name="Google Shape;179;p8"/>
+          <p:cNvPr id="168" name="Google Shape;168;p8"/>
           <p:cNvSpPr/>
           <p:nvPr/>
         </p:nvSpPr>
@@ -12637,7 +11859,7 @@
       </p:sp>
       <p:sp>
         <p:nvSpPr>
-          <p:cNvPr id="180" name="Google Shape;180;p8"/>
+          <p:cNvPr id="169" name="Google Shape;169;p8"/>
           <p:cNvSpPr/>
           <p:nvPr/>
         </p:nvSpPr>
@@ -12703,7 +11925,7 @@
       </p:sp>
       <p:sp>
         <p:nvSpPr>
-          <p:cNvPr id="181" name="Google Shape;181;p8"/>
+          <p:cNvPr id="170" name="Google Shape;170;p8"/>
           <p:cNvSpPr/>
           <p:nvPr/>
         </p:nvSpPr>
@@ -12766,7 +11988,7 @@
       </p:sp>
       <p:sp>
         <p:nvSpPr>
-          <p:cNvPr id="182" name="Google Shape;182;p8"/>
+          <p:cNvPr id="171" name="Google Shape;171;p8"/>
           <p:cNvSpPr/>
           <p:nvPr/>
         </p:nvSpPr>
@@ -12847,7 +12069,7 @@
     </p:bg>
     <p:spTree>
       <p:nvGrpSpPr>
-        <p:cNvPr id="187" name="Shape 187"/>
+        <p:cNvPr id="176" name="Shape 176"/>
         <p:cNvGrpSpPr/>
         <p:nvPr/>
       </p:nvGrpSpPr>
@@ -12861,7 +12083,7 @@
       </p:grpSpPr>
       <p:sp>
         <p:nvSpPr>
-          <p:cNvPr id="188" name="Google Shape;188;p9"/>
+          <p:cNvPr id="177" name="Google Shape;177;p9"/>
           <p:cNvSpPr/>
           <p:nvPr/>
         </p:nvSpPr>
@@ -12924,7 +12146,7 @@
       </p:sp>
       <p:sp>
         <p:nvSpPr>
-          <p:cNvPr id="189" name="Google Shape;189;p9"/>
+          <p:cNvPr id="178" name="Google Shape;178;p9"/>
           <p:cNvSpPr/>
           <p:nvPr/>
         </p:nvSpPr>
@@ -12969,7 +12191,7 @@
       </p:sp>
       <p:sp>
         <p:nvSpPr>
-          <p:cNvPr id="190" name="Google Shape;190;p9"/>
+          <p:cNvPr id="179" name="Google Shape;179;p9"/>
           <p:cNvSpPr/>
           <p:nvPr/>
         </p:nvSpPr>
@@ -13032,7 +12254,7 @@
       </p:sp>
       <p:sp>
         <p:nvSpPr>
-          <p:cNvPr id="191" name="Google Shape;191;p9"/>
+          <p:cNvPr id="180" name="Google Shape;180;p9"/>
           <p:cNvSpPr/>
           <p:nvPr/>
         </p:nvSpPr>
@@ -13082,7 +12304,19 @@
                 <a:cs typeface="Source Serif 4"/>
                 <a:sym typeface="Source Serif 4"/>
               </a:rPr>
-              <a:t>Kanban en GitHub Projects, tres fases, 13 semanas</a:t>
+              <a:t>Kanban en GitHub Projects</a:t>
+            </a:r>
+            <a:r>
+              <a:rPr b="0" i="0" lang="en-US" sz="5550" u="none" cap="none" strike="noStrike">
+                <a:solidFill>
+                  <a:srgbClr val="0F3460"/>
+                </a:solidFill>
+                <a:latin typeface="Source Serif 4"/>
+                <a:ea typeface="Source Serif 4"/>
+                <a:cs typeface="Source Serif 4"/>
+                <a:sym typeface="Source Serif 4"/>
+              </a:rPr>
+              <a:t>, tres fases, 13 semanas</a:t>
             </a:r>
             <a:endParaRPr b="0" i="0" sz="5550" u="none" cap="none" strike="noStrike">
               <a:solidFill>
@@ -13098,7 +12332,7 @@
       </p:sp>
       <p:sp>
         <p:nvSpPr>
-          <p:cNvPr id="192" name="Google Shape;192;p9"/>
+          <p:cNvPr id="181" name="Google Shape;181;p9"/>
           <p:cNvSpPr/>
           <p:nvPr/>
         </p:nvSpPr>
@@ -13164,7 +12398,7 @@
       </p:sp>
       <p:sp>
         <p:nvSpPr>
-          <p:cNvPr id="193" name="Google Shape;193;p9"/>
+          <p:cNvPr id="182" name="Google Shape;182;p9"/>
           <p:cNvSpPr/>
           <p:nvPr/>
         </p:nvSpPr>
@@ -13209,7 +12443,7 @@
       </p:sp>
       <p:sp>
         <p:nvSpPr>
-          <p:cNvPr id="194" name="Google Shape;194;p9"/>
+          <p:cNvPr id="183" name="Google Shape;183;p9"/>
           <p:cNvSpPr/>
           <p:nvPr/>
         </p:nvSpPr>
@@ -13254,7 +12488,7 @@
       </p:sp>
       <p:sp>
         <p:nvSpPr>
-          <p:cNvPr id="195" name="Google Shape;195;p9"/>
+          <p:cNvPr id="184" name="Google Shape;184;p9"/>
           <p:cNvSpPr/>
           <p:nvPr/>
         </p:nvSpPr>
@@ -13317,7 +12551,7 @@
       </p:sp>
       <p:sp>
         <p:nvSpPr>
-          <p:cNvPr id="196" name="Google Shape;196;p9"/>
+          <p:cNvPr id="185" name="Google Shape;185;p9"/>
           <p:cNvSpPr/>
           <p:nvPr/>
         </p:nvSpPr>
@@ -13380,7 +12614,7 @@
       </p:sp>
       <p:sp>
         <p:nvSpPr>
-          <p:cNvPr id="197" name="Google Shape;197;p9"/>
+          <p:cNvPr id="186" name="Google Shape;186;p9"/>
           <p:cNvSpPr/>
           <p:nvPr/>
         </p:nvSpPr>
@@ -13425,7 +12659,7 @@
       </p:sp>
       <p:sp>
         <p:nvSpPr>
-          <p:cNvPr id="198" name="Google Shape;198;p9"/>
+          <p:cNvPr id="187" name="Google Shape;187;p9"/>
           <p:cNvSpPr/>
           <p:nvPr/>
         </p:nvSpPr>
@@ -13470,7 +12704,7 @@
       </p:sp>
       <p:sp>
         <p:nvSpPr>
-          <p:cNvPr id="199" name="Google Shape;199;p9"/>
+          <p:cNvPr id="188" name="Google Shape;188;p9"/>
           <p:cNvSpPr/>
           <p:nvPr/>
         </p:nvSpPr>
@@ -13533,7 +12767,7 @@
       </p:sp>
       <p:sp>
         <p:nvSpPr>
-          <p:cNvPr id="200" name="Google Shape;200;p9"/>
+          <p:cNvPr id="189" name="Google Shape;189;p9"/>
           <p:cNvSpPr/>
           <p:nvPr/>
         </p:nvSpPr>
@@ -13596,7 +12830,7 @@
       </p:sp>
       <p:sp>
         <p:nvSpPr>
-          <p:cNvPr id="201" name="Google Shape;201;p9"/>
+          <p:cNvPr id="190" name="Google Shape;190;p9"/>
           <p:cNvSpPr/>
           <p:nvPr/>
         </p:nvSpPr>
@@ -13641,7 +12875,7 @@
       </p:sp>
       <p:sp>
         <p:nvSpPr>
-          <p:cNvPr id="202" name="Google Shape;202;p9"/>
+          <p:cNvPr id="191" name="Google Shape;191;p9"/>
           <p:cNvSpPr/>
           <p:nvPr/>
         </p:nvSpPr>
@@ -13686,7 +12920,7 @@
       </p:sp>
       <p:sp>
         <p:nvSpPr>
-          <p:cNvPr id="203" name="Google Shape;203;p9"/>
+          <p:cNvPr id="192" name="Google Shape;192;p9"/>
           <p:cNvSpPr/>
           <p:nvPr/>
         </p:nvSpPr>
@@ -13749,7 +12983,7 @@
       </p:sp>
       <p:sp>
         <p:nvSpPr>
-          <p:cNvPr id="204" name="Google Shape;204;p9"/>
+          <p:cNvPr id="193" name="Google Shape;193;p9"/>
           <p:cNvSpPr/>
           <p:nvPr/>
         </p:nvSpPr>
@@ -13812,7 +13046,7 @@
       </p:sp>
       <p:sp>
         <p:nvSpPr>
-          <p:cNvPr id="205" name="Google Shape;205;p9"/>
+          <p:cNvPr id="194" name="Google Shape;194;p9"/>
           <p:cNvSpPr/>
           <p:nvPr/>
         </p:nvSpPr>
@@ -13855,7 +13089,7 @@
       </p:sp>
       <p:sp>
         <p:nvSpPr>
-          <p:cNvPr id="206" name="Google Shape;206;p9"/>
+          <p:cNvPr id="195" name="Google Shape;195;p9"/>
           <p:cNvSpPr/>
           <p:nvPr/>
         </p:nvSpPr>
@@ -13900,7 +13134,7 @@
       </p:sp>
       <p:sp>
         <p:nvSpPr>
-          <p:cNvPr id="207" name="Google Shape;207;p9"/>
+          <p:cNvPr id="196" name="Google Shape;196;p9"/>
           <p:cNvSpPr/>
           <p:nvPr/>
         </p:nvSpPr>
@@ -13963,7 +13197,7 @@
       </p:sp>
       <p:sp>
         <p:nvSpPr>
-          <p:cNvPr id="208" name="Google Shape;208;p9"/>
+          <p:cNvPr id="197" name="Google Shape;197;p9"/>
           <p:cNvSpPr/>
           <p:nvPr/>
         </p:nvSpPr>
@@ -14029,7 +13263,7 @@
       </p:sp>
       <p:sp>
         <p:nvSpPr>
-          <p:cNvPr id="209" name="Google Shape;209;p9"/>
+          <p:cNvPr id="198" name="Google Shape;198;p9"/>
           <p:cNvSpPr/>
           <p:nvPr/>
         </p:nvSpPr>
@@ -14095,7 +13329,7 @@
       </p:sp>
       <p:sp>
         <p:nvSpPr>
-          <p:cNvPr id="210" name="Google Shape;210;p9"/>
+          <p:cNvPr id="199" name="Google Shape;199;p9"/>
           <p:cNvSpPr/>
           <p:nvPr/>
         </p:nvSpPr>
@@ -14158,7 +13392,7 @@
       </p:sp>
       <p:sp>
         <p:nvSpPr>
-          <p:cNvPr id="211" name="Google Shape;211;p9"/>
+          <p:cNvPr id="200" name="Google Shape;200;p9"/>
           <p:cNvSpPr/>
           <p:nvPr/>
         </p:nvSpPr>
@@ -14203,7 +13437,7 @@
       </p:sp>
       <p:sp>
         <p:nvSpPr>
-          <p:cNvPr id="212" name="Google Shape;212;p9"/>
+          <p:cNvPr id="201" name="Google Shape;201;p9"/>
           <p:cNvSpPr/>
           <p:nvPr/>
         </p:nvSpPr>
@@ -14266,7 +13500,7 @@
       </p:sp>
       <p:sp>
         <p:nvSpPr>
-          <p:cNvPr id="213" name="Google Shape;213;p9"/>
+          <p:cNvPr id="202" name="Google Shape;202;p9"/>
           <p:cNvSpPr/>
           <p:nvPr/>
         </p:nvSpPr>
@@ -14332,7 +13566,7 @@
       </p:sp>
       <p:sp>
         <p:nvSpPr>
-          <p:cNvPr id="214" name="Google Shape;214;p9"/>
+          <p:cNvPr id="203" name="Google Shape;203;p9"/>
           <p:cNvSpPr/>
           <p:nvPr/>
         </p:nvSpPr>
@@ -14410,7 +13644,7 @@
       </p:sp>
       <p:sp>
         <p:nvSpPr>
-          <p:cNvPr id="215" name="Google Shape;215;p9"/>
+          <p:cNvPr id="204" name="Google Shape;204;p9"/>
           <p:cNvSpPr/>
           <p:nvPr/>
         </p:nvSpPr>
@@ -14473,7 +13707,7 @@
       </p:sp>
       <p:sp>
         <p:nvSpPr>
-          <p:cNvPr id="216" name="Google Shape;216;p9"/>
+          <p:cNvPr id="205" name="Google Shape;205;p9"/>
           <p:cNvSpPr/>
           <p:nvPr/>
         </p:nvSpPr>
@@ -14518,7 +13752,7 @@
       </p:sp>
       <p:sp>
         <p:nvSpPr>
-          <p:cNvPr id="217" name="Google Shape;217;p9"/>
+          <p:cNvPr id="206" name="Google Shape;206;p9"/>
           <p:cNvSpPr/>
           <p:nvPr/>
         </p:nvSpPr>
@@ -14581,7 +13815,7 @@
       </p:sp>
       <p:sp>
         <p:nvSpPr>
-          <p:cNvPr id="218" name="Google Shape;218;p9"/>
+          <p:cNvPr id="207" name="Google Shape;207;p9"/>
           <p:cNvSpPr/>
           <p:nvPr/>
         </p:nvSpPr>
@@ -14647,7 +13881,7 @@
       </p:sp>
       <p:sp>
         <p:nvSpPr>
-          <p:cNvPr id="219" name="Google Shape;219;p9"/>
+          <p:cNvPr id="208" name="Google Shape;208;p9"/>
           <p:cNvSpPr/>
           <p:nvPr/>
         </p:nvSpPr>
@@ -14725,7 +13959,7 @@
       </p:sp>
       <p:sp>
         <p:nvSpPr>
-          <p:cNvPr id="220" name="Google Shape;220;p9"/>
+          <p:cNvPr id="209" name="Google Shape;209;p9"/>
           <p:cNvSpPr/>
           <p:nvPr/>
         </p:nvSpPr>
@@ -14816,7 +14050,7 @@
       </p:sp>
       <p:sp>
         <p:nvSpPr>
-          <p:cNvPr id="221" name="Google Shape;221;p9"/>
+          <p:cNvPr id="210" name="Google Shape;210;p9"/>
           <p:cNvSpPr/>
           <p:nvPr/>
         </p:nvSpPr>
@@ -14861,7 +14095,7 @@
       </p:sp>
       <p:sp>
         <p:nvSpPr>
-          <p:cNvPr id="222" name="Google Shape;222;p9"/>
+          <p:cNvPr id="211" name="Google Shape;211;p9"/>
           <p:cNvSpPr/>
           <p:nvPr/>
         </p:nvSpPr>
@@ -14924,7 +14158,7 @@
       </p:sp>
       <p:sp>
         <p:nvSpPr>
-          <p:cNvPr id="223" name="Google Shape;223;p9"/>
+          <p:cNvPr id="212" name="Google Shape;212;p9"/>
           <p:cNvSpPr/>
           <p:nvPr/>
         </p:nvSpPr>
@@ -14990,7 +14224,7 @@
       </p:sp>
       <p:sp>
         <p:nvSpPr>
-          <p:cNvPr id="224" name="Google Shape;224;p9"/>
+          <p:cNvPr id="213" name="Google Shape;213;p9"/>
           <p:cNvSpPr/>
           <p:nvPr/>
         </p:nvSpPr>
@@ -15068,7 +14302,7 @@
       </p:sp>
       <p:sp>
         <p:nvSpPr>
-          <p:cNvPr id="225" name="Google Shape;225;p9"/>
+          <p:cNvPr id="214" name="Google Shape;214;p9"/>
           <p:cNvSpPr/>
           <p:nvPr/>
         </p:nvSpPr>
@@ -15131,7 +14365,7 @@
       </p:sp>
       <p:sp>
         <p:nvSpPr>
-          <p:cNvPr id="226" name="Google Shape;226;p9"/>
+          <p:cNvPr id="215" name="Google Shape;215;p9"/>
           <p:cNvSpPr/>
           <p:nvPr/>
         </p:nvSpPr>
@@ -15176,7 +14410,7 @@
       </p:sp>
       <p:sp>
         <p:nvSpPr>
-          <p:cNvPr id="227" name="Google Shape;227;p9"/>
+          <p:cNvPr id="216" name="Google Shape;216;p9"/>
           <p:cNvSpPr/>
           <p:nvPr/>
         </p:nvSpPr>
@@ -15239,7 +14473,7 @@
       </p:sp>
       <p:sp>
         <p:nvSpPr>
-          <p:cNvPr id="228" name="Google Shape;228;p9"/>
+          <p:cNvPr id="217" name="Google Shape;217;p9"/>
           <p:cNvSpPr/>
           <p:nvPr/>
         </p:nvSpPr>
@@ -15305,7 +14539,7 @@
       </p:sp>
       <p:sp>
         <p:nvSpPr>
-          <p:cNvPr id="229" name="Google Shape;229;p9"/>
+          <p:cNvPr id="218" name="Google Shape;218;p9"/>
           <p:cNvSpPr/>
           <p:nvPr/>
         </p:nvSpPr>
@@ -15383,7 +14617,7 @@
       </p:sp>
       <p:sp>
         <p:nvSpPr>
-          <p:cNvPr id="230" name="Google Shape;230;p9"/>
+          <p:cNvPr id="219" name="Google Shape;219;p9"/>
           <p:cNvSpPr/>
           <p:nvPr/>
         </p:nvSpPr>
@@ -15446,7 +14680,7 @@
       </p:sp>
       <p:sp>
         <p:nvSpPr>
-          <p:cNvPr id="231" name="Google Shape;231;p9"/>
+          <p:cNvPr id="220" name="Google Shape;220;p9"/>
           <p:cNvSpPr/>
           <p:nvPr/>
         </p:nvSpPr>
@@ -15491,7 +14725,7 @@
       </p:sp>
       <p:sp>
         <p:nvSpPr>
-          <p:cNvPr id="232" name="Google Shape;232;p9"/>
+          <p:cNvPr id="221" name="Google Shape;221;p9"/>
           <p:cNvSpPr/>
           <p:nvPr/>
         </p:nvSpPr>
@@ -15554,7 +14788,7 @@
       </p:sp>
       <p:sp>
         <p:nvSpPr>
-          <p:cNvPr id="233" name="Google Shape;233;p9"/>
+          <p:cNvPr id="222" name="Google Shape;222;p9"/>
           <p:cNvSpPr/>
           <p:nvPr/>
         </p:nvSpPr>
@@ -15620,7 +14854,7 @@
       </p:sp>
       <p:sp>
         <p:nvSpPr>
-          <p:cNvPr id="234" name="Google Shape;234;p9"/>
+          <p:cNvPr id="223" name="Google Shape;223;p9"/>
           <p:cNvSpPr/>
           <p:nvPr/>
         </p:nvSpPr>
@@ -15686,7 +14920,7 @@
       </p:sp>
       <p:sp>
         <p:nvSpPr>
-          <p:cNvPr id="235" name="Google Shape;235;p9"/>
+          <p:cNvPr id="224" name="Google Shape;224;p9"/>
           <p:cNvSpPr/>
           <p:nvPr/>
         </p:nvSpPr>
@@ -15749,7 +14983,7 @@
       </p:sp>
       <p:sp>
         <p:nvSpPr>
-          <p:cNvPr id="236" name="Google Shape;236;p9"/>
+          <p:cNvPr id="225" name="Google Shape;225;p9"/>
           <p:cNvSpPr/>
           <p:nvPr/>
         </p:nvSpPr>
@@ -15812,7 +15046,7 @@
       </p:sp>
       <p:sp>
         <p:nvSpPr>
-          <p:cNvPr id="237" name="Google Shape;237;p9"/>
+          <p:cNvPr id="226" name="Google Shape;226;p9"/>
           <p:cNvSpPr/>
           <p:nvPr/>
         </p:nvSpPr>
@@ -15893,7 +15127,7 @@
     </p:bg>
     <p:spTree>
       <p:nvGrpSpPr>
-        <p:cNvPr id="242" name="Shape 242"/>
+        <p:cNvPr id="231" name="Shape 231"/>
         <p:cNvGrpSpPr/>
         <p:nvPr/>
       </p:nvGrpSpPr>
@@ -15907,7 +15141,7 @@
       </p:grpSpPr>
       <p:sp>
         <p:nvSpPr>
-          <p:cNvPr id="243" name="Google Shape;243;p10"/>
+          <p:cNvPr id="232" name="Google Shape;232;p10"/>
           <p:cNvSpPr/>
           <p:nvPr/>
         </p:nvSpPr>
@@ -15952,7 +15186,7 @@
       </p:sp>
       <p:sp>
         <p:nvSpPr>
-          <p:cNvPr id="244" name="Google Shape;244;p10"/>
+          <p:cNvPr id="233" name="Google Shape;233;p10"/>
           <p:cNvSpPr/>
           <p:nvPr/>
         </p:nvSpPr>
@@ -16015,7 +15249,7 @@
       </p:sp>
       <p:sp>
         <p:nvSpPr>
-          <p:cNvPr id="245" name="Google Shape;245;p10"/>
+          <p:cNvPr id="234" name="Google Shape;234;p10"/>
           <p:cNvSpPr/>
           <p:nvPr/>
         </p:nvSpPr>
@@ -16081,7 +15315,7 @@
       </p:sp>
       <p:sp>
         <p:nvSpPr>
-          <p:cNvPr id="246" name="Google Shape;246;p10"/>
+          <p:cNvPr id="235" name="Google Shape;235;p10"/>
           <p:cNvSpPr/>
           <p:nvPr/>
         </p:nvSpPr>
@@ -16124,7 +15358,7 @@
       </p:sp>
       <p:sp>
         <p:nvSpPr>
-          <p:cNvPr id="247" name="Google Shape;247;p10"/>
+          <p:cNvPr id="236" name="Google Shape;236;p10"/>
           <p:cNvSpPr/>
           <p:nvPr/>
         </p:nvSpPr>
@@ -16190,7 +15424,7 @@
       </p:sp>
       <p:sp>
         <p:nvSpPr>
-          <p:cNvPr id="248" name="Google Shape;248;p10"/>
+          <p:cNvPr id="237" name="Google Shape;237;p10"/>
           <p:cNvSpPr/>
           <p:nvPr/>
         </p:nvSpPr>
@@ -16256,7 +15490,7 @@
       </p:sp>
       <p:sp>
         <p:nvSpPr>
-          <p:cNvPr id="249" name="Google Shape;249;p10"/>
+          <p:cNvPr id="238" name="Google Shape;238;p10"/>
           <p:cNvSpPr/>
           <p:nvPr/>
         </p:nvSpPr>
@@ -16299,7 +15533,7 @@
       </p:sp>
       <p:sp>
         <p:nvSpPr>
-          <p:cNvPr id="250" name="Google Shape;250;p10"/>
+          <p:cNvPr id="239" name="Google Shape;239;p10"/>
           <p:cNvSpPr/>
           <p:nvPr/>
         </p:nvSpPr>
@@ -16365,7 +15599,7 @@
       </p:sp>
       <p:sp>
         <p:nvSpPr>
-          <p:cNvPr id="251" name="Google Shape;251;p10"/>
+          <p:cNvPr id="240" name="Google Shape;240;p10"/>
           <p:cNvSpPr/>
           <p:nvPr/>
         </p:nvSpPr>
@@ -16431,7 +15665,7 @@
       </p:sp>
       <p:sp>
         <p:nvSpPr>
-          <p:cNvPr id="252" name="Google Shape;252;p10"/>
+          <p:cNvPr id="241" name="Google Shape;241;p10"/>
           <p:cNvSpPr/>
           <p:nvPr/>
         </p:nvSpPr>
@@ -16474,7 +15708,7 @@
       </p:sp>
       <p:sp>
         <p:nvSpPr>
-          <p:cNvPr id="253" name="Google Shape;253;p10"/>
+          <p:cNvPr id="242" name="Google Shape;242;p10"/>
           <p:cNvSpPr/>
           <p:nvPr/>
         </p:nvSpPr>
@@ -16540,7 +15774,7 @@
       </p:sp>
       <p:sp>
         <p:nvSpPr>
-          <p:cNvPr id="254" name="Google Shape;254;p10"/>
+          <p:cNvPr id="243" name="Google Shape;243;p10"/>
           <p:cNvSpPr/>
           <p:nvPr/>
         </p:nvSpPr>
@@ -16606,7 +15840,7 @@
       </p:sp>
       <p:sp>
         <p:nvSpPr>
-          <p:cNvPr id="255" name="Google Shape;255;p10"/>
+          <p:cNvPr id="244" name="Google Shape;244;p10"/>
           <p:cNvSpPr/>
           <p:nvPr/>
         </p:nvSpPr>
@@ -16651,7 +15885,7 @@
       </p:sp>
       <p:sp>
         <p:nvSpPr>
-          <p:cNvPr id="256" name="Google Shape;256;p10"/>
+          <p:cNvPr id="245" name="Google Shape;245;p10"/>
           <p:cNvSpPr/>
           <p:nvPr/>
         </p:nvSpPr>
@@ -16696,7 +15930,7 @@
       </p:sp>
       <p:sp>
         <p:nvSpPr>
-          <p:cNvPr id="257" name="Google Shape;257;p10"/>
+          <p:cNvPr id="246" name="Google Shape;246;p10"/>
           <p:cNvSpPr/>
           <p:nvPr/>
         </p:nvSpPr>
@@ -16759,7 +15993,7 @@
       </p:sp>
       <p:sp>
         <p:nvSpPr>
-          <p:cNvPr id="258" name="Google Shape;258;p10"/>
+          <p:cNvPr id="247" name="Google Shape;247;p10"/>
           <p:cNvSpPr/>
           <p:nvPr/>
         </p:nvSpPr>
@@ -16825,7 +16059,7 @@
       </p:sp>
       <p:sp>
         <p:nvSpPr>
-          <p:cNvPr id="259" name="Google Shape;259;p10"/>
+          <p:cNvPr id="248" name="Google Shape;248;p10"/>
           <p:cNvSpPr/>
           <p:nvPr/>
         </p:nvSpPr>
@@ -16891,7 +16125,7 @@
       </p:sp>
       <p:sp>
         <p:nvSpPr>
-          <p:cNvPr id="260" name="Google Shape;260;p10"/>
+          <p:cNvPr id="249" name="Google Shape;249;p10"/>
           <p:cNvSpPr/>
           <p:nvPr/>
         </p:nvSpPr>
@@ -16936,7 +16170,7 @@
       </p:sp>
       <p:sp>
         <p:nvSpPr>
-          <p:cNvPr id="261" name="Google Shape;261;p10"/>
+          <p:cNvPr id="250" name="Google Shape;250;p10"/>
           <p:cNvSpPr/>
           <p:nvPr/>
         </p:nvSpPr>
@@ -16981,7 +16215,7 @@
       </p:sp>
       <p:sp>
         <p:nvSpPr>
-          <p:cNvPr id="262" name="Google Shape;262;p10"/>
+          <p:cNvPr id="251" name="Google Shape;251;p10"/>
           <p:cNvSpPr/>
           <p:nvPr/>
         </p:nvSpPr>
@@ -17044,7 +16278,7 @@
       </p:sp>
       <p:sp>
         <p:nvSpPr>
-          <p:cNvPr id="263" name="Google Shape;263;p10"/>
+          <p:cNvPr id="252" name="Google Shape;252;p10"/>
           <p:cNvSpPr/>
           <p:nvPr/>
         </p:nvSpPr>
@@ -17110,7 +16344,7 @@
       </p:sp>
       <p:sp>
         <p:nvSpPr>
-          <p:cNvPr id="264" name="Google Shape;264;p10"/>
+          <p:cNvPr id="253" name="Google Shape;253;p10"/>
           <p:cNvSpPr/>
           <p:nvPr/>
         </p:nvSpPr>
@@ -17176,7 +16410,7 @@
       </p:sp>
       <p:sp>
         <p:nvSpPr>
-          <p:cNvPr id="265" name="Google Shape;265;p10"/>
+          <p:cNvPr id="254" name="Google Shape;254;p10"/>
           <p:cNvSpPr/>
           <p:nvPr/>
         </p:nvSpPr>
@@ -17239,7 +16473,7 @@
       </p:sp>
       <p:sp>
         <p:nvSpPr>
-          <p:cNvPr id="266" name="Google Shape;266;p10"/>
+          <p:cNvPr id="255" name="Google Shape;255;p10"/>
           <p:cNvSpPr/>
           <p:nvPr/>
         </p:nvSpPr>
@@ -17320,7 +16554,7 @@
     </p:bg>
     <p:spTree>
       <p:nvGrpSpPr>
-        <p:cNvPr id="271" name="Shape 271"/>
+        <p:cNvPr id="260" name="Shape 260"/>
         <p:cNvGrpSpPr/>
         <p:nvPr/>
       </p:nvGrpSpPr>
@@ -17334,7 +16568,7 @@
       </p:grpSpPr>
       <p:sp>
         <p:nvSpPr>
-          <p:cNvPr id="272" name="Google Shape;272;p11"/>
+          <p:cNvPr id="261" name="Google Shape;261;p11"/>
           <p:cNvSpPr/>
           <p:nvPr/>
         </p:nvSpPr>
@@ -17397,7 +16631,7 @@
       </p:sp>
       <p:sp>
         <p:nvSpPr>
-          <p:cNvPr id="273" name="Google Shape;273;p11"/>
+          <p:cNvPr id="262" name="Google Shape;262;p11"/>
           <p:cNvSpPr/>
           <p:nvPr/>
         </p:nvSpPr>
@@ -17442,7 +16676,7 @@
       </p:sp>
       <p:sp>
         <p:nvSpPr>
-          <p:cNvPr id="274" name="Google Shape;274;p11"/>
+          <p:cNvPr id="263" name="Google Shape;263;p11"/>
           <p:cNvSpPr/>
           <p:nvPr/>
         </p:nvSpPr>
@@ -17505,7 +16739,7 @@
       </p:sp>
       <p:sp>
         <p:nvSpPr>
-          <p:cNvPr id="275" name="Google Shape;275;p11"/>
+          <p:cNvPr id="264" name="Google Shape;264;p11"/>
           <p:cNvSpPr/>
           <p:nvPr/>
         </p:nvSpPr>
@@ -17571,7 +16805,7 @@
       </p:sp>
       <p:sp>
         <p:nvSpPr>
-          <p:cNvPr id="276" name="Google Shape;276;p11"/>
+          <p:cNvPr id="265" name="Google Shape;265;p11"/>
           <p:cNvSpPr/>
           <p:nvPr/>
         </p:nvSpPr>
@@ -17612,7 +16846,7 @@
               <a:buNone/>
             </a:pPr>
             <a:r>
-              <a:rPr b="0" i="0" lang="en-US" sz="2325" u="none" cap="none" strike="noStrike">
+              <a:rPr lang="en-US" sz="2325">
                 <a:solidFill>
                   <a:srgbClr val="3D4D60"/>
                 </a:solidFill>
@@ -17621,7 +16855,19 @@
                 <a:cs typeface="Manrope"/>
                 <a:sym typeface="Manrope"/>
               </a:rPr>
-              <a:t>Cinco evidencias del cumplimiento de lo planificado.</a:t>
+              <a:t>Cuatro </a:t>
+            </a:r>
+            <a:r>
+              <a:rPr b="0" i="0" lang="en-US" sz="2325" u="none" cap="none" strike="noStrike">
+                <a:solidFill>
+                  <a:srgbClr val="3D4D60"/>
+                </a:solidFill>
+                <a:latin typeface="Manrope"/>
+                <a:ea typeface="Manrope"/>
+                <a:cs typeface="Manrope"/>
+                <a:sym typeface="Manrope"/>
+              </a:rPr>
+              <a:t>evidencias del cumplimiento de lo planificado.</a:t>
             </a:r>
             <a:endParaRPr b="0" i="0" sz="2325" u="none" cap="none" strike="noStrike">
               <a:solidFill>
@@ -17637,7 +16883,7 @@
       </p:sp>
       <p:sp>
         <p:nvSpPr>
-          <p:cNvPr id="277" name="Google Shape;277;p11"/>
+          <p:cNvPr id="266" name="Google Shape;266;p11"/>
           <p:cNvSpPr/>
           <p:nvPr/>
         </p:nvSpPr>
@@ -17682,7 +16928,7 @@
       </p:sp>
       <p:sp>
         <p:nvSpPr>
-          <p:cNvPr id="278" name="Google Shape;278;p11"/>
+          <p:cNvPr id="267" name="Google Shape;267;p11"/>
           <p:cNvSpPr/>
           <p:nvPr/>
         </p:nvSpPr>
@@ -17745,7 +16991,7 @@
       </p:sp>
       <p:sp>
         <p:nvSpPr>
-          <p:cNvPr id="279" name="Google Shape;279;p11"/>
+          <p:cNvPr id="268" name="Google Shape;268;p11"/>
           <p:cNvSpPr/>
           <p:nvPr/>
         </p:nvSpPr>
@@ -17808,7 +17054,7 @@
       </p:sp>
       <p:sp>
         <p:nvSpPr>
-          <p:cNvPr id="280" name="Google Shape;280;p11"/>
+          <p:cNvPr id="269" name="Google Shape;269;p11"/>
           <p:cNvSpPr/>
           <p:nvPr/>
         </p:nvSpPr>
@@ -17874,7 +17120,7 @@
       </p:sp>
       <p:sp>
         <p:nvSpPr>
-          <p:cNvPr id="281" name="Google Shape;281;p11"/>
+          <p:cNvPr id="270" name="Google Shape;270;p11"/>
           <p:cNvSpPr/>
           <p:nvPr/>
         </p:nvSpPr>
@@ -17919,7 +17165,7 @@
       </p:sp>
       <p:sp>
         <p:nvSpPr>
-          <p:cNvPr id="282" name="Google Shape;282;p11"/>
+          <p:cNvPr id="271" name="Google Shape;271;p11"/>
           <p:cNvSpPr/>
           <p:nvPr/>
         </p:nvSpPr>
@@ -17982,7 +17228,7 @@
       </p:sp>
       <p:sp>
         <p:nvSpPr>
-          <p:cNvPr id="283" name="Google Shape;283;p11"/>
+          <p:cNvPr id="272" name="Google Shape;272;p11"/>
           <p:cNvSpPr/>
           <p:nvPr/>
         </p:nvSpPr>
@@ -18045,7 +17291,7 @@
       </p:sp>
       <p:sp>
         <p:nvSpPr>
-          <p:cNvPr id="284" name="Google Shape;284;p11"/>
+          <p:cNvPr id="273" name="Google Shape;273;p11"/>
           <p:cNvSpPr/>
           <p:nvPr/>
         </p:nvSpPr>
@@ -18111,7 +17357,7 @@
       </p:sp>
       <p:sp>
         <p:nvSpPr>
-          <p:cNvPr id="285" name="Google Shape;285;p11"/>
+          <p:cNvPr id="274" name="Google Shape;274;p11"/>
           <p:cNvSpPr/>
           <p:nvPr/>
         </p:nvSpPr>
@@ -18156,7 +17402,7 @@
       </p:sp>
       <p:sp>
         <p:nvSpPr>
-          <p:cNvPr id="286" name="Google Shape;286;p11"/>
+          <p:cNvPr id="275" name="Google Shape;275;p11"/>
           <p:cNvSpPr/>
           <p:nvPr/>
         </p:nvSpPr>
@@ -18219,7 +17465,7 @@
       </p:sp>
       <p:sp>
         <p:nvSpPr>
-          <p:cNvPr id="287" name="Google Shape;287;p11"/>
+          <p:cNvPr id="276" name="Google Shape;276;p11"/>
           <p:cNvSpPr/>
           <p:nvPr/>
         </p:nvSpPr>
@@ -18257,7 +17503,7 @@
               <a:buNone/>
             </a:pPr>
             <a:r>
-              <a:rPr b="1" i="0" lang="en-US" sz="2475" u="none" cap="none" strike="noStrike">
+              <a:rPr b="1" lang="en-US" sz="2475">
                 <a:solidFill>
                   <a:srgbClr val="0F3460"/>
                 </a:solidFill>
@@ -18266,7 +17512,7 @@
                 <a:cs typeface="Manrope"/>
                 <a:sym typeface="Manrope"/>
               </a:rPr>
-              <a:t>Prototipo funcional VR</a:t>
+              <a:t>Diseño conceptual</a:t>
             </a:r>
             <a:endParaRPr b="0" i="0" sz="2475" u="none" cap="none" strike="noStrike">
               <a:solidFill>
@@ -18282,7 +17528,7 @@
       </p:sp>
       <p:sp>
         <p:nvSpPr>
-          <p:cNvPr id="288" name="Google Shape;288;p11"/>
+          <p:cNvPr id="277" name="Google Shape;277;p11"/>
           <p:cNvSpPr/>
           <p:nvPr/>
         </p:nvSpPr>
@@ -18323,7 +17569,7 @@
               <a:buNone/>
             </a:pPr>
             <a:r>
-              <a:rPr b="0" i="0" lang="en-US" sz="2025" u="none" cap="none" strike="noStrike">
+              <a:rPr lang="en-US" sz="2025">
                 <a:solidFill>
                   <a:srgbClr val="4A4A4A"/>
                 </a:solidFill>
@@ -18332,7 +17578,7 @@
                 <a:cs typeface="Manrope"/>
                 <a:sym typeface="Manrope"/>
               </a:rPr>
-              <a:t>El recorrido completo funciona en visor.</a:t>
+              <a:t>Prototipo que representa el recorrido esperado</a:t>
             </a:r>
             <a:endParaRPr b="0" i="0" sz="2025" u="none" cap="none" strike="noStrike">
               <a:solidFill>
@@ -18348,7 +17594,7 @@
       </p:sp>
       <p:sp>
         <p:nvSpPr>
-          <p:cNvPr id="289" name="Google Shape;289;p11"/>
+          <p:cNvPr id="278" name="Google Shape;278;p11"/>
           <p:cNvSpPr/>
           <p:nvPr/>
         </p:nvSpPr>
@@ -18393,7 +17639,7 @@
       </p:sp>
       <p:sp>
         <p:nvSpPr>
-          <p:cNvPr id="290" name="Google Shape;290;p11"/>
+          <p:cNvPr id="279" name="Google Shape;279;p11"/>
           <p:cNvSpPr/>
           <p:nvPr/>
         </p:nvSpPr>
@@ -18456,7 +17702,7 @@
       </p:sp>
       <p:sp>
         <p:nvSpPr>
-          <p:cNvPr id="291" name="Google Shape;291;p11"/>
+          <p:cNvPr id="280" name="Google Shape;280;p11"/>
           <p:cNvSpPr/>
           <p:nvPr/>
         </p:nvSpPr>
@@ -18519,7 +17765,7 @@
       </p:sp>
       <p:sp>
         <p:nvSpPr>
-          <p:cNvPr id="292" name="Google Shape;292;p11"/>
+          <p:cNvPr id="281" name="Google Shape;281;p11"/>
           <p:cNvSpPr/>
           <p:nvPr/>
         </p:nvSpPr>
@@ -18585,244 +17831,7 @@
       </p:sp>
       <p:sp>
         <p:nvSpPr>
-          <p:cNvPr id="293" name="Google Shape;293;p11"/>
-          <p:cNvSpPr/>
-          <p:nvPr/>
-        </p:nvSpPr>
-        <p:spPr>
-          <a:xfrm>
-            <a:off x="952500" y="8888382"/>
-            <a:ext cx="16383000" cy="1009650"/>
-          </a:xfrm>
-          <a:prstGeom prst="rect">
-            <a:avLst/>
-          </a:prstGeom>
-          <a:solidFill>
-            <a:srgbClr val="FFFFFF">
-              <a:alpha val="67059"/>
-            </a:srgbClr>
-          </a:solidFill>
-          <a:ln>
-            <a:noFill/>
-          </a:ln>
-        </p:spPr>
-        <p:txBody>
-          <a:bodyPr anchorCtr="0" anchor="ctr" bIns="91425" lIns="91425" spcFirstLastPara="1" rIns="91425" wrap="square" tIns="91425">
-            <a:noAutofit/>
-          </a:bodyPr>
-          <a:lstStyle/>
-          <a:p>
-            <a:pPr indent="0" lvl="0" marL="0" rtl="0" algn="l">
-              <a:spcBef>
-                <a:spcPts val="0"/>
-              </a:spcBef>
-              <a:spcAft>
-                <a:spcPts val="0"/>
-              </a:spcAft>
-              <a:buNone/>
-            </a:pPr>
-            <a:r>
-              <a:t/>
-            </a:r>
-            <a:endParaRPr/>
-          </a:p>
-        </p:txBody>
-      </p:sp>
-      <p:sp>
-        <p:nvSpPr>
-          <p:cNvPr id="294" name="Google Shape;294;p11"/>
-          <p:cNvSpPr/>
-          <p:nvPr/>
-        </p:nvSpPr>
-        <p:spPr>
-          <a:xfrm>
-            <a:off x="1333500" y="9174132"/>
-            <a:ext cx="838200" cy="476250"/>
-          </a:xfrm>
-          <a:prstGeom prst="rect">
-            <a:avLst/>
-          </a:prstGeom>
-          <a:noFill/>
-          <a:ln>
-            <a:noFill/>
-          </a:ln>
-        </p:spPr>
-        <p:txBody>
-          <a:bodyPr anchorCtr="0" anchor="t" bIns="25400" lIns="25400" spcFirstLastPara="1" rIns="25400" wrap="square" tIns="25400">
-            <a:noAutofit/>
-          </a:bodyPr>
-          <a:lstStyle/>
-          <a:p>
-            <a:pPr indent="0" lvl="0" marL="0" marR="0" rtl="0" algn="l">
-              <a:spcBef>
-                <a:spcPts val="0"/>
-              </a:spcBef>
-              <a:spcAft>
-                <a:spcPts val="0"/>
-              </a:spcAft>
-              <a:buClr>
-                <a:srgbClr val="C594AA"/>
-              </a:buClr>
-              <a:buSzPts val="2550"/>
-              <a:buFont typeface="Manrope"/>
-              <a:buNone/>
-            </a:pPr>
-            <a:r>
-              <a:rPr b="1" i="0" lang="en-US" sz="2550" u="none" cap="none" strike="noStrike">
-                <a:solidFill>
-                  <a:srgbClr val="C594AA"/>
-                </a:solidFill>
-                <a:latin typeface="Manrope"/>
-                <a:ea typeface="Manrope"/>
-                <a:cs typeface="Manrope"/>
-                <a:sym typeface="Manrope"/>
-              </a:rPr>
-              <a:t>05</a:t>
-            </a:r>
-            <a:endParaRPr b="0" i="0" sz="2550" u="none" cap="none" strike="noStrike">
-              <a:solidFill>
-                <a:schemeClr val="dk1"/>
-              </a:solidFill>
-              <a:latin typeface="Calibri"/>
-              <a:ea typeface="Calibri"/>
-              <a:cs typeface="Calibri"/>
-              <a:sym typeface="Calibri"/>
-            </a:endParaRPr>
-          </a:p>
-        </p:txBody>
-      </p:sp>
-      <p:sp>
-        <p:nvSpPr>
-          <p:cNvPr id="295" name="Google Shape;295;p11"/>
-          <p:cNvSpPr/>
-          <p:nvPr/>
-        </p:nvSpPr>
-        <p:spPr>
-          <a:xfrm>
-            <a:off x="2476500" y="9177307"/>
-            <a:ext cx="7212340" cy="469900"/>
-          </a:xfrm>
-          <a:prstGeom prst="rect">
-            <a:avLst/>
-          </a:prstGeom>
-          <a:noFill/>
-          <a:ln>
-            <a:noFill/>
-          </a:ln>
-        </p:spPr>
-        <p:txBody>
-          <a:bodyPr anchorCtr="0" anchor="t" bIns="25400" lIns="25400" spcFirstLastPara="1" rIns="25400" wrap="square" tIns="25400">
-            <a:noAutofit/>
-          </a:bodyPr>
-          <a:lstStyle/>
-          <a:p>
-            <a:pPr indent="0" lvl="0" marL="0" marR="0" rtl="0" algn="l">
-              <a:spcBef>
-                <a:spcPts val="0"/>
-              </a:spcBef>
-              <a:spcAft>
-                <a:spcPts val="0"/>
-              </a:spcAft>
-              <a:buClr>
-                <a:srgbClr val="0F3460"/>
-              </a:buClr>
-              <a:buSzPts val="2475"/>
-              <a:buFont typeface="Manrope"/>
-              <a:buNone/>
-            </a:pPr>
-            <a:r>
-              <a:rPr b="1" i="0" lang="en-US" sz="2475" u="none" cap="none" strike="noStrike">
-                <a:solidFill>
-                  <a:srgbClr val="0F3460"/>
-                </a:solidFill>
-                <a:latin typeface="Manrope"/>
-                <a:ea typeface="Manrope"/>
-                <a:cs typeface="Manrope"/>
-                <a:sym typeface="Manrope"/>
-              </a:rPr>
-              <a:t>Base de datos anonimizada</a:t>
-            </a:r>
-            <a:endParaRPr b="0" i="0" sz="2475" u="none" cap="none" strike="noStrike">
-              <a:solidFill>
-                <a:schemeClr val="dk1"/>
-              </a:solidFill>
-              <a:latin typeface="Calibri"/>
-              <a:ea typeface="Calibri"/>
-              <a:cs typeface="Calibri"/>
-              <a:sym typeface="Calibri"/>
-            </a:endParaRPr>
-          </a:p>
-        </p:txBody>
-      </p:sp>
-      <p:sp>
-        <p:nvSpPr>
-          <p:cNvPr id="296" name="Google Shape;296;p11"/>
-          <p:cNvSpPr/>
-          <p:nvPr/>
-        </p:nvSpPr>
-        <p:spPr>
-          <a:xfrm>
-            <a:off x="9414173" y="9206775"/>
-            <a:ext cx="8294251" cy="410964"/>
-          </a:xfrm>
-          <a:prstGeom prst="rect">
-            <a:avLst/>
-          </a:prstGeom>
-          <a:noFill/>
-          <a:ln>
-            <a:noFill/>
-          </a:ln>
-        </p:spPr>
-        <p:txBody>
-          <a:bodyPr anchorCtr="0" anchor="t" bIns="25400" lIns="25400" spcFirstLastPara="1" rIns="25400" wrap="square" tIns="25400">
-            <a:noAutofit/>
-          </a:bodyPr>
-          <a:lstStyle/>
-          <a:p>
-            <a:pPr indent="0" lvl="0" marL="0" marR="0" rtl="0" algn="l">
-              <a:lnSpc>
-                <a:spcPct val="106773"/>
-              </a:lnSpc>
-              <a:spcBef>
-                <a:spcPts val="0"/>
-              </a:spcBef>
-              <a:spcAft>
-                <a:spcPts val="0"/>
-              </a:spcAft>
-              <a:buClr>
-                <a:srgbClr val="4A4A4A"/>
-              </a:buClr>
-              <a:buSzPts val="2025"/>
-              <a:buFont typeface="Manrope"/>
-              <a:buNone/>
-            </a:pPr>
-            <a:r>
-              <a:rPr b="0" i="0" lang="en-US" sz="2025" u="none" cap="none" strike="noStrike">
-                <a:solidFill>
-                  <a:srgbClr val="4A4A4A"/>
-                </a:solidFill>
-                <a:latin typeface="Manrope"/>
-                <a:ea typeface="Manrope"/>
-                <a:cs typeface="Manrope"/>
-                <a:sym typeface="Manrope"/>
-              </a:rPr>
-              <a:t>Los datos se resguardan sin identificar a nadie.</a:t>
-            </a:r>
-            <a:endParaRPr b="0" i="0" sz="2025" u="none" cap="none" strike="noStrike">
-              <a:solidFill>
-                <a:schemeClr val="dk1"/>
-              </a:solidFill>
-              <a:latin typeface="Calibri"/>
-              <a:ea typeface="Calibri"/>
-              <a:cs typeface="Calibri"/>
-              <a:sym typeface="Calibri"/>
-            </a:endParaRPr>
-          </a:p>
-        </p:txBody>
-      </p:sp>
-      <p:sp>
-        <p:nvSpPr>
-          <p:cNvPr id="297" name="Google Shape;297;p11"/>
+          <p:cNvPr id="282" name="Google Shape;282;p11"/>
           <p:cNvSpPr/>
           <p:nvPr/>
         </p:nvSpPr>
@@ -18885,7 +17894,7 @@
       </p:sp>
       <p:sp>
         <p:nvSpPr>
-          <p:cNvPr id="298" name="Google Shape;298;p11"/>
+          <p:cNvPr id="283" name="Google Shape;283;p11"/>
           <p:cNvSpPr/>
           <p:nvPr/>
         </p:nvSpPr>

</xml_diff>